<commit_message>
updated release notes version and date
</commit_message>
<xml_diff>
--- a/Documentation/User Manual Source/Release Notes Vecto4.x.pptx
+++ b/Documentation/User Manual Source/Release Notes Vecto4.x.pptx
@@ -220,7 +220,7 @@
           <a:p>
             <a:fld id="{390E69D5-8A05-43AD-B5FD-86D96081B052}" type="datetimeFigureOut">
               <a:rPr lang="de-AT" smtClean="0"/>
-              <a:t>12.10.2023</a:t>
+              <a:t>17.10.2023</a:t>
             </a:fld>
             <a:endParaRPr lang="de-AT"/>
           </a:p>
@@ -1971,7 +1971,7 @@
                 <a:latin typeface="Arial"/>
                 <a:ea typeface="DejaVu Sans"/>
               </a:rPr>
-              <a:t>VECTO 4.0.0.3210 </a:t>
+              <a:t>VECTO 4.0.0.3211 </a:t>
             </a:r>
             <a:endParaRPr lang="en-US" sz="3200" b="0" strike="noStrike" spc="-1" dirty="0">
               <a:latin typeface="Arial"/>
@@ -1995,7 +1995,7 @@
                 <a:latin typeface="Arial"/>
                 <a:ea typeface="DejaVu Sans"/>
               </a:rPr>
-              <a:t>16</a:t>
+              <a:t>17</a:t>
             </a:r>
             <a:r>
               <a:rPr lang="en-US" sz="2000" b="1" strike="noStrike" spc="-1" dirty="0">

</xml_diff>

<commit_message>
updating user manual (version, changelog)
</commit_message>
<xml_diff>
--- a/Documentation/User Manual Source/Release Notes Vecto4.x.pptx
+++ b/Documentation/User Manual Source/Release Notes Vecto4.x.pptx
@@ -220,7 +220,7 @@
           <a:p>
             <a:fld id="{390E69D5-8A05-43AD-B5FD-86D96081B052}" type="datetimeFigureOut">
               <a:rPr lang="de-AT" smtClean="0"/>
-              <a:t>12.10.2023</a:t>
+              <a:t>17.10.2023</a:t>
             </a:fld>
             <a:endParaRPr lang="de-AT"/>
           </a:p>
@@ -2203,6 +2203,13 @@
               <a:t>nd Amendment </a:t>
             </a:r>
             <a:br>
+              <a:rPr lang="en-US" sz="2400" b="1" dirty="0"/>
+            </a:br>
+            <a:r>
+              <a:rPr lang="en-US" sz="2400" b="1" dirty="0"/>
+              <a:t>of Regulation (EU) 2017/2400</a:t>
+            </a:r>
+            <a:br>
               <a:rPr lang="en-US" sz="2800" b="1" dirty="0"/>
             </a:br>
             <a:br>
@@ -2284,8 +2291,8 @@
         </p:nvSpPr>
         <p:spPr>
           <a:xfrm>
-            <a:off x="588206" y="932447"/>
-            <a:ext cx="8394645" cy="5254889"/>
+            <a:off x="588206" y="1140311"/>
+            <a:ext cx="8394645" cy="5047025"/>
           </a:xfrm>
         </p:spPr>
         <p:txBody>
@@ -2295,8 +2302,11 @@
           <a:lstStyle/>
           <a:p>
             <a:pPr>
-              <a:spcBef>
-                <a:spcPts val="1200"/>
+              <a:lnSpc>
+                <a:spcPct val="120000"/>
+              </a:lnSpc>
+              <a:spcBef>
+                <a:spcPts val="600"/>
               </a:spcBef>
             </a:pPr>
             <a:r>
@@ -2306,8 +2316,11 @@
           </a:p>
           <a:p>
             <a:pPr lvl="1">
-              <a:spcBef>
-                <a:spcPts val="1200"/>
+              <a:lnSpc>
+                <a:spcPct val="120000"/>
+              </a:lnSpc>
+              <a:spcBef>
+                <a:spcPts val="600"/>
               </a:spcBef>
             </a:pPr>
             <a:r>
@@ -2321,8 +2334,11 @@
           </a:p>
           <a:p>
             <a:pPr lvl="1">
-              <a:spcBef>
-                <a:spcPts val="1200"/>
+              <a:lnSpc>
+                <a:spcPct val="120000"/>
+              </a:lnSpc>
+              <a:spcBef>
+                <a:spcPts val="600"/>
               </a:spcBef>
             </a:pPr>
             <a:r>
@@ -2332,8 +2348,11 @@
           </a:p>
           <a:p>
             <a:pPr lvl="1">
-              <a:spcBef>
-                <a:spcPts val="1200"/>
+              <a:lnSpc>
+                <a:spcPct val="120000"/>
+              </a:lnSpc>
+              <a:spcBef>
+                <a:spcPts val="600"/>
               </a:spcBef>
             </a:pPr>
             <a:r>
@@ -2347,8 +2366,11 @@
           </a:p>
           <a:p>
             <a:pPr lvl="1">
-              <a:spcBef>
-                <a:spcPts val="1200"/>
+              <a:lnSpc>
+                <a:spcPct val="120000"/>
+              </a:lnSpc>
+              <a:spcBef>
+                <a:spcPts val="600"/>
               </a:spcBef>
             </a:pPr>
             <a:r>
@@ -2358,8 +2380,11 @@
           </a:p>
           <a:p>
             <a:pPr lvl="1">
-              <a:spcBef>
-                <a:spcPts val="1200"/>
+              <a:lnSpc>
+                <a:spcPct val="120000"/>
+              </a:lnSpc>
+              <a:spcBef>
+                <a:spcPts val="600"/>
               </a:spcBef>
             </a:pPr>
             <a:r>
@@ -2373,8 +2398,11 @@
           </a:p>
           <a:p>
             <a:pPr>
-              <a:spcBef>
-                <a:spcPts val="1200"/>
+              <a:lnSpc>
+                <a:spcPct val="120000"/>
+              </a:lnSpc>
+              <a:spcBef>
+                <a:spcPts val="600"/>
               </a:spcBef>
             </a:pPr>
             <a:r>
@@ -2384,8 +2412,11 @@
           </a:p>
           <a:p>
             <a:pPr>
-              <a:spcBef>
-                <a:spcPts val="1200"/>
+              <a:lnSpc>
+                <a:spcPct val="120000"/>
+              </a:lnSpc>
+              <a:spcBef>
+                <a:spcPts val="600"/>
               </a:spcBef>
             </a:pPr>
             <a:r>
@@ -2395,8 +2426,11 @@
           </a:p>
           <a:p>
             <a:pPr lvl="1">
-              <a:spcBef>
-                <a:spcPts val="1200"/>
+              <a:lnSpc>
+                <a:spcPct val="120000"/>
+              </a:lnSpc>
+              <a:spcBef>
+                <a:spcPts val="600"/>
               </a:spcBef>
             </a:pPr>
             <a:r>
@@ -2410,8 +2444,11 @@
           </a:p>
           <a:p>
             <a:pPr>
-              <a:spcBef>
-                <a:spcPts val="1200"/>
+              <a:lnSpc>
+                <a:spcPct val="120000"/>
+              </a:lnSpc>
+              <a:spcBef>
+                <a:spcPts val="600"/>
               </a:spcBef>
             </a:pPr>
             <a:r>
@@ -2421,8 +2458,11 @@
           </a:p>
           <a:p>
             <a:pPr lvl="1">
-              <a:spcBef>
-                <a:spcPts val="1200"/>
+              <a:lnSpc>
+                <a:spcPct val="120000"/>
+              </a:lnSpc>
+              <a:spcBef>
+                <a:spcPts val="600"/>
               </a:spcBef>
             </a:pPr>
             <a:r>
@@ -2433,8 +2473,11 @@
           </a:p>
           <a:p>
             <a:pPr lvl="1">
-              <a:spcBef>
-                <a:spcPts val="1200"/>
+              <a:lnSpc>
+                <a:spcPct val="120000"/>
+              </a:lnSpc>
+              <a:spcBef>
+                <a:spcPts val="600"/>
               </a:spcBef>
             </a:pPr>
             <a:r>
@@ -2445,8 +2488,11 @@
           </a:p>
           <a:p>
             <a:pPr lvl="1">
-              <a:spcBef>
-                <a:spcPts val="1200"/>
+              <a:lnSpc>
+                <a:spcPct val="120000"/>
+              </a:lnSpc>
+              <a:spcBef>
+                <a:spcPts val="600"/>
               </a:spcBef>
             </a:pPr>
             <a:r>
@@ -2457,8 +2503,11 @@
           </a:p>
           <a:p>
             <a:pPr>
-              <a:spcBef>
-                <a:spcPts val="1200"/>
+              <a:lnSpc>
+                <a:spcPct val="120000"/>
+              </a:lnSpc>
+              <a:spcBef>
+                <a:spcPts val="600"/>
               </a:spcBef>
             </a:pPr>
             <a:r>
@@ -2468,8 +2517,11 @@
           </a:p>
           <a:p>
             <a:pPr>
-              <a:spcBef>
-                <a:spcPts val="1200"/>
+              <a:lnSpc>
+                <a:spcPct val="120000"/>
+              </a:lnSpc>
+              <a:spcBef>
+                <a:spcPts val="600"/>
               </a:spcBef>
             </a:pPr>
             <a:r>
@@ -2479,16 +2531,22 @@
           </a:p>
           <a:p>
             <a:pPr>
-              <a:spcBef>
-                <a:spcPts val="1200"/>
+              <a:lnSpc>
+                <a:spcPct val="120000"/>
+              </a:lnSpc>
+              <a:spcBef>
+                <a:spcPts val="600"/>
               </a:spcBef>
             </a:pPr>
             <a:endParaRPr lang="pt-BR" sz="2000" dirty="0"/>
           </a:p>
           <a:p>
             <a:pPr>
-              <a:spcBef>
-                <a:spcPts val="1200"/>
+              <a:lnSpc>
+                <a:spcPct val="120000"/>
+              </a:lnSpc>
+              <a:spcBef>
+                <a:spcPts val="600"/>
               </a:spcBef>
             </a:pPr>
             <a:r>

</xml_diff>

<commit_message>
updating version number, updating release notes
</commit_message>
<xml_diff>
--- a/Documentation/User Manual Source/Release Notes Vecto4.x.pptx
+++ b/Documentation/User Manual Source/Release Notes Vecto4.x.pptx
@@ -5,17 +5,18 @@
     <p:sldMasterId id="2147483661" r:id="rId1"/>
   </p:sldMasterIdLst>
   <p:notesMasterIdLst>
-    <p:notesMasterId r:id="rId10"/>
+    <p:notesMasterId r:id="rId11"/>
   </p:notesMasterIdLst>
   <p:sldIdLst>
     <p:sldId id="256" r:id="rId2"/>
-    <p:sldId id="1320" r:id="rId3"/>
-    <p:sldId id="1289" r:id="rId4"/>
-    <p:sldId id="1314" r:id="rId5"/>
-    <p:sldId id="1318" r:id="rId6"/>
-    <p:sldId id="1315" r:id="rId7"/>
-    <p:sldId id="1319" r:id="rId8"/>
-    <p:sldId id="1316" r:id="rId9"/>
+    <p:sldId id="258" r:id="rId3"/>
+    <p:sldId id="1320" r:id="rId4"/>
+    <p:sldId id="1289" r:id="rId5"/>
+    <p:sldId id="1314" r:id="rId6"/>
+    <p:sldId id="1318" r:id="rId7"/>
+    <p:sldId id="1315" r:id="rId8"/>
+    <p:sldId id="1319" r:id="rId9"/>
+    <p:sldId id="1316" r:id="rId10"/>
   </p:sldIdLst>
   <p:sldSz cx="9144000" cy="6858000" type="screen4x3"/>
   <p:notesSz cx="7772400" cy="10058400"/>
@@ -120,6 +121,7 @@
         <p14:section name="Standardabschnitt" id="{9B5D7305-A192-4B1D-99D4-70BE9E08F5C8}">
           <p14:sldIdLst>
             <p14:sldId id="256"/>
+            <p14:sldId id="258"/>
             <p14:sldId id="1320"/>
             <p14:sldId id="1289"/>
             <p14:sldId id="1314"/>
@@ -220,7 +222,7 @@
           <a:p>
             <a:fld id="{390E69D5-8A05-43AD-B5FD-86D96081B052}" type="datetimeFigureOut">
               <a:rPr lang="de-AT" smtClean="0"/>
-              <a:t>17.10.2023</a:t>
+              <a:t>23.10.2023</a:t>
             </a:fld>
             <a:endParaRPr lang="de-AT"/>
           </a:p>
@@ -923,6 +925,36 @@
 </p:sldLayout>
 </file>
 
+<file path=ppt/slideLayouts/slideLayout4.xml><?xml version="1.0" encoding="utf-8"?>
+<p:sldLayout xmlns:a="http://schemas.openxmlformats.org/drawingml/2006/main" xmlns:r="http://schemas.openxmlformats.org/officeDocument/2006/relationships" xmlns:p="http://schemas.openxmlformats.org/presentationml/2006/main" type="blank">
+  <p:cSld name="1_Blank Slide">
+    <p:spTree>
+      <p:nvGrpSpPr>
+        <p:cNvPr id="1" name=""/>
+        <p:cNvGrpSpPr/>
+        <p:nvPr/>
+      </p:nvGrpSpPr>
+      <p:grpSpPr>
+        <a:xfrm>
+          <a:off x="0" y="0"/>
+          <a:ext cx="0" cy="0"/>
+          <a:chOff x="0" y="0"/>
+          <a:chExt cx="0" cy="0"/>
+        </a:xfrm>
+      </p:grpSpPr>
+    </p:spTree>
+    <p:extLst>
+      <p:ext uri="{BB962C8B-B14F-4D97-AF65-F5344CB8AC3E}">
+        <p14:creationId xmlns:p14="http://schemas.microsoft.com/office/powerpoint/2010/main" val="3052418887"/>
+      </p:ext>
+    </p:extLst>
+  </p:cSld>
+  <p:clrMapOvr>
+    <a:masterClrMapping/>
+  </p:clrMapOvr>
+</p:sldLayout>
+</file>
+
 <file path=ppt/slideMasters/slideMaster1.xml><?xml version="1.0" encoding="utf-8"?>
 <p:sldMaster xmlns:a="http://schemas.openxmlformats.org/drawingml/2006/main" xmlns:r="http://schemas.openxmlformats.org/officeDocument/2006/relationships" xmlns:p="http://schemas.openxmlformats.org/presentationml/2006/main">
   <p:cSld>
@@ -1113,7 +1145,7 @@
           <p:nvPr/>
         </p:nvPicPr>
         <p:blipFill>
-          <a:blip r:embed="rId5"/>
+          <a:blip r:embed="rId6"/>
           <a:stretch/>
         </p:blipFill>
         <p:spPr>
@@ -1136,7 +1168,7 @@
           <p:nvPr/>
         </p:nvPicPr>
         <p:blipFill>
-          <a:blip r:embed="rId6"/>
+          <a:blip r:embed="rId7"/>
           <a:stretch/>
         </p:blipFill>
         <p:spPr>
@@ -1397,6 +1429,7 @@
     <p:sldLayoutId id="2147483662" r:id="rId1"/>
     <p:sldLayoutId id="2147483676" r:id="rId2"/>
     <p:sldLayoutId id="2147483677" r:id="rId3"/>
+    <p:sldLayoutId id="2147483678" r:id="rId4"/>
   </p:sldLayoutIdLst>
   <p:hf sldNum="0" hdr="0" ftr="0" dt="0"/>
   <p:txStyles>
@@ -1919,6 +1952,406 @@
       </p:grpSpPr>
       <p:sp>
         <p:nvSpPr>
+          <p:cNvPr id="92" name="PlaceHolder 1"/>
+          <p:cNvSpPr>
+            <a:spLocks noGrp="1"/>
+          </p:cNvSpPr>
+          <p:nvPr>
+            <p:ph type="title"/>
+          </p:nvPr>
+        </p:nvSpPr>
+        <p:spPr>
+          <a:xfrm>
+            <a:off x="468360" y="476640"/>
+            <a:ext cx="8217720" cy="680400"/>
+          </a:xfrm>
+          <a:prstGeom prst="rect">
+            <a:avLst/>
+          </a:prstGeom>
+          <a:noFill/>
+          <a:ln w="0">
+            <a:noFill/>
+          </a:ln>
+        </p:spPr>
+        <p:txBody>
+          <a:bodyPr lIns="90000" tIns="45000" rIns="90000" bIns="45000" numCol="1" spcCol="0" anchor="ctr">
+            <a:noAutofit/>
+          </a:bodyPr>
+          <a:lstStyle/>
+          <a:p>
+            <a:pPr algn="ctr">
+              <a:lnSpc>
+                <a:spcPct val="100000"/>
+              </a:lnSpc>
+              <a:buNone/>
+            </a:pPr>
+            <a:r>
+              <a:rPr lang="en-US" sz="2400" b="1" strike="noStrike" spc="-1" dirty="0">
+                <a:solidFill>
+                  <a:srgbClr val="990000"/>
+                </a:solidFill>
+                <a:latin typeface="Arial"/>
+              </a:rPr>
+              <a:t>Vecto 4.0.1.3217 OFFICIAL RELEASE</a:t>
+            </a:r>
+            <a:br>
+              <a:rPr sz="2400" dirty="0"/>
+            </a:br>
+            <a:r>
+              <a:rPr lang="en-US" sz="1600" spc="-1" dirty="0">
+                <a:latin typeface="Arial"/>
+              </a:rPr>
+              <a:t>23.10.2023</a:t>
+            </a:r>
+            <a:endParaRPr lang="en-US" sz="1600" b="0" strike="noStrike" spc="-1" dirty="0">
+              <a:latin typeface="Arial"/>
+            </a:endParaRPr>
+          </a:p>
+        </p:txBody>
+      </p:sp>
+      <p:sp>
+        <p:nvSpPr>
+          <p:cNvPr id="93" name="PlaceHolder 2"/>
+          <p:cNvSpPr>
+            <a:spLocks noGrp="1"/>
+          </p:cNvSpPr>
+          <p:nvPr>
+            <p:ph/>
+          </p:nvPr>
+        </p:nvSpPr>
+        <p:spPr>
+          <a:xfrm>
+            <a:off x="323640" y="1268640"/>
+            <a:ext cx="8496360" cy="4823640"/>
+          </a:xfrm>
+          <a:prstGeom prst="rect">
+            <a:avLst/>
+          </a:prstGeom>
+          <a:noFill/>
+          <a:ln w="0">
+            <a:noFill/>
+          </a:ln>
+        </p:spPr>
+        <p:txBody>
+          <a:bodyPr lIns="90000" tIns="45000" rIns="90000" bIns="45000" numCol="1" spcCol="0" anchor="t">
+            <a:noAutofit/>
+          </a:bodyPr>
+          <a:lstStyle/>
+          <a:p>
+            <a:pPr marL="343080" indent="-343080">
+              <a:lnSpc>
+                <a:spcPct val="100000"/>
+              </a:lnSpc>
+              <a:spcBef>
+                <a:spcPts val="320"/>
+              </a:spcBef>
+              <a:buClr>
+                <a:srgbClr val="000000"/>
+              </a:buClr>
+              <a:buFont typeface="Symbol"/>
+              <a:buChar char=""/>
+              <a:tabLst>
+                <a:tab pos="1886040" algn="l"/>
+              </a:tabLst>
+            </a:pPr>
+            <a:r>
+              <a:rPr lang="en-US" sz="1600" b="1" spc="-1" dirty="0">
+                <a:solidFill>
+                  <a:srgbClr val="000000"/>
+                </a:solidFill>
+              </a:rPr>
+              <a:t>Improvements</a:t>
+            </a:r>
+          </a:p>
+          <a:p>
+            <a:pPr marL="800280" lvl="1" indent="-343080">
+              <a:lnSpc>
+                <a:spcPct val="100000"/>
+              </a:lnSpc>
+              <a:spcBef>
+                <a:spcPts val="320"/>
+              </a:spcBef>
+              <a:buClr>
+                <a:srgbClr val="000000"/>
+              </a:buClr>
+              <a:buFont typeface="Symbol"/>
+              <a:buChar char=""/>
+              <a:tabLst>
+                <a:tab pos="1886040" algn="l"/>
+              </a:tabLst>
+            </a:pPr>
+            <a:r>
+              <a:rPr lang="en-US" sz="1400" spc="-1" dirty="0">
+                <a:solidFill>
+                  <a:srgbClr val="000000"/>
+                </a:solidFill>
+              </a:rPr>
+              <a:t>VTP mode: create zip archive for input and output files</a:t>
+            </a:r>
+          </a:p>
+          <a:p>
+            <a:pPr marL="343080" indent="-343080">
+              <a:lnSpc>
+                <a:spcPct val="100000"/>
+              </a:lnSpc>
+              <a:spcBef>
+                <a:spcPts val="320"/>
+              </a:spcBef>
+              <a:buClr>
+                <a:srgbClr val="000000"/>
+              </a:buClr>
+              <a:buFont typeface="Symbol"/>
+              <a:buChar char=""/>
+              <a:tabLst>
+                <a:tab pos="1886040" algn="l"/>
+              </a:tabLst>
+            </a:pPr>
+            <a:r>
+              <a:rPr lang="en-US" sz="1600" b="1" spc="-1" dirty="0">
+                <a:solidFill>
+                  <a:srgbClr val="000000"/>
+                </a:solidFill>
+              </a:rPr>
+              <a:t>- Bugfixes</a:t>
+            </a:r>
+          </a:p>
+          <a:p>
+            <a:pPr marL="800280" lvl="1" indent="-343080">
+              <a:lnSpc>
+                <a:spcPct val="100000"/>
+              </a:lnSpc>
+              <a:spcBef>
+                <a:spcPts val="320"/>
+              </a:spcBef>
+              <a:buClr>
+                <a:srgbClr val="000000"/>
+              </a:buClr>
+              <a:buFont typeface="Symbol"/>
+              <a:buChar char=""/>
+              <a:tabLst>
+                <a:tab pos="1886040" algn="l"/>
+              </a:tabLst>
+            </a:pPr>
+            <a:r>
+              <a:rPr lang="en-US" sz="1400" spc="-1" dirty="0">
+                <a:solidFill>
+                  <a:srgbClr val="000000"/>
+                </a:solidFill>
+              </a:rPr>
+              <a:t>bugfix in CIF for complete(d) buses - do not write </a:t>
+            </a:r>
+            <a:r>
+              <a:rPr lang="en-US" sz="1400" spc="-1" dirty="0" err="1">
+                <a:solidFill>
+                  <a:srgbClr val="000000"/>
+                </a:solidFill>
+              </a:rPr>
+              <a:t>PrimaryVehicleSubgroup</a:t>
+            </a:r>
+            <a:r>
+              <a:rPr lang="en-US" sz="1400" spc="-1" dirty="0">
+                <a:solidFill>
+                  <a:srgbClr val="000000"/>
+                </a:solidFill>
+              </a:rPr>
+              <a:t> element</a:t>
+            </a:r>
+          </a:p>
+          <a:p>
+            <a:pPr marL="800280" lvl="1" indent="-343080">
+              <a:lnSpc>
+                <a:spcPct val="100000"/>
+              </a:lnSpc>
+              <a:spcBef>
+                <a:spcPts val="320"/>
+              </a:spcBef>
+              <a:buClr>
+                <a:srgbClr val="000000"/>
+              </a:buClr>
+              <a:buFont typeface="Symbol"/>
+              <a:buChar char=""/>
+              <a:tabLst>
+                <a:tab pos="1886040" algn="l"/>
+              </a:tabLst>
+            </a:pPr>
+            <a:r>
+              <a:rPr lang="en-US" sz="1400" spc="-1" dirty="0">
+                <a:solidFill>
+                  <a:srgbClr val="000000"/>
+                </a:solidFill>
+              </a:rPr>
+              <a:t>fix hybrid strategy: power comparison</a:t>
+            </a:r>
+          </a:p>
+          <a:p>
+            <a:pPr marL="800280" lvl="1" indent="-343080">
+              <a:lnSpc>
+                <a:spcPct val="100000"/>
+              </a:lnSpc>
+              <a:spcBef>
+                <a:spcPts val="320"/>
+              </a:spcBef>
+              <a:buClr>
+                <a:srgbClr val="000000"/>
+              </a:buClr>
+              <a:buFont typeface="Symbol"/>
+              <a:buChar char=""/>
+              <a:tabLst>
+                <a:tab pos="1886040" algn="l"/>
+              </a:tabLst>
+            </a:pPr>
+            <a:r>
+              <a:rPr lang="en-US" sz="1400" spc="-1" dirty="0">
+                <a:solidFill>
+                  <a:srgbClr val="000000"/>
+                </a:solidFill>
+              </a:rPr>
+              <a:t>fix exempted vehicles do not work (error message that XML version is not supported)</a:t>
+            </a:r>
+          </a:p>
+          <a:p>
+            <a:pPr marL="800280" lvl="1" indent="-343080">
+              <a:lnSpc>
+                <a:spcPct val="100000"/>
+              </a:lnSpc>
+              <a:spcBef>
+                <a:spcPts val="320"/>
+              </a:spcBef>
+              <a:buClr>
+                <a:srgbClr val="000000"/>
+              </a:buClr>
+              <a:buFont typeface="Symbol"/>
+              <a:buChar char=""/>
+              <a:tabLst>
+                <a:tab pos="1886040" algn="l"/>
+              </a:tabLst>
+            </a:pPr>
+            <a:r>
+              <a:rPr lang="en-US" sz="1400" spc="-1" dirty="0">
+                <a:solidFill>
+                  <a:srgbClr val="000000"/>
+                </a:solidFill>
+              </a:rPr>
+              <a:t>bugfix in XML schema: remove wrong PS technology entry for lorries</a:t>
+            </a:r>
+          </a:p>
+          <a:p>
+            <a:pPr marL="800280" lvl="1" indent="-343080">
+              <a:lnSpc>
+                <a:spcPct val="100000"/>
+              </a:lnSpc>
+              <a:spcBef>
+                <a:spcPts val="320"/>
+              </a:spcBef>
+              <a:buClr>
+                <a:srgbClr val="000000"/>
+              </a:buClr>
+              <a:buFont typeface="Symbol"/>
+              <a:buChar char=""/>
+              <a:tabLst>
+                <a:tab pos="1886040" algn="l"/>
+              </a:tabLst>
+            </a:pPr>
+            <a:r>
+              <a:rPr lang="en-US" sz="1400" spc="-1" dirty="0">
+                <a:solidFill>
+                  <a:srgbClr val="000000"/>
+                </a:solidFill>
+              </a:rPr>
+              <a:t>bugfix for conditioning power demand for IHPC vehicles</a:t>
+            </a:r>
+            <a:endParaRPr lang="en-US" sz="1050" strike="noStrike" spc="-1" dirty="0">
+              <a:latin typeface="Arial"/>
+            </a:endParaRPr>
+          </a:p>
+          <a:p>
+            <a:pPr>
+              <a:lnSpc>
+                <a:spcPct val="100000"/>
+              </a:lnSpc>
+              <a:buNone/>
+              <a:tabLst>
+                <a:tab pos="1886040" algn="l"/>
+              </a:tabLst>
+            </a:pPr>
+            <a:endParaRPr lang="en-US" sz="1400" b="0" strike="noStrike" spc="-1" dirty="0">
+              <a:latin typeface="Arial"/>
+            </a:endParaRPr>
+          </a:p>
+          <a:p>
+            <a:pPr>
+              <a:lnSpc>
+                <a:spcPct val="100000"/>
+              </a:lnSpc>
+              <a:spcBef>
+                <a:spcPts val="281"/>
+              </a:spcBef>
+              <a:buNone/>
+              <a:tabLst>
+                <a:tab pos="1886040" algn="l"/>
+              </a:tabLst>
+            </a:pPr>
+            <a:endParaRPr lang="en-US" sz="1400" b="0" strike="noStrike" spc="-1" dirty="0">
+              <a:latin typeface="Arial"/>
+            </a:endParaRPr>
+          </a:p>
+          <a:p>
+            <a:pPr>
+              <a:lnSpc>
+                <a:spcPct val="100000"/>
+              </a:lnSpc>
+              <a:buNone/>
+              <a:tabLst>
+                <a:tab pos="1886040" algn="l"/>
+              </a:tabLst>
+            </a:pPr>
+            <a:endParaRPr lang="en-US" sz="1400" b="0" strike="noStrike" spc="-1" dirty="0">
+              <a:latin typeface="Arial"/>
+            </a:endParaRPr>
+          </a:p>
+          <a:p>
+            <a:pPr>
+              <a:lnSpc>
+                <a:spcPct val="100000"/>
+              </a:lnSpc>
+              <a:buNone/>
+              <a:tabLst>
+                <a:tab pos="1886040" algn="l"/>
+              </a:tabLst>
+            </a:pPr>
+            <a:endParaRPr lang="en-US" sz="1400" b="0" strike="noStrike" spc="-1" dirty="0">
+              <a:latin typeface="Arial"/>
+            </a:endParaRPr>
+          </a:p>
+        </p:txBody>
+      </p:sp>
+    </p:spTree>
+  </p:cSld>
+  <p:clrMapOvr>
+    <a:masterClrMapping/>
+  </p:clrMapOvr>
+</p:sld>
+</file>
+
+<file path=ppt/slides/slide3.xml><?xml version="1.0" encoding="utf-8"?>
+<p:sld xmlns:a="http://schemas.openxmlformats.org/drawingml/2006/main" xmlns:r="http://schemas.openxmlformats.org/officeDocument/2006/relationships" xmlns:p="http://schemas.openxmlformats.org/presentationml/2006/main">
+  <p:cSld>
+    <p:spTree>
+      <p:nvGrpSpPr>
+        <p:cNvPr id="1" name=""/>
+        <p:cNvGrpSpPr/>
+        <p:nvPr/>
+      </p:nvGrpSpPr>
+      <p:grpSpPr>
+        <a:xfrm>
+          <a:off x="0" y="0"/>
+          <a:ext cx="0" cy="0"/>
+          <a:chOff x="0" y="0"/>
+          <a:chExt cx="0" cy="0"/>
+        </a:xfrm>
+      </p:grpSpPr>
+      <p:sp>
+        <p:nvSpPr>
           <p:cNvPr id="88" name="Text Box 94"/>
           <p:cNvSpPr/>
           <p:nvPr/>
@@ -2143,7 +2576,7 @@
 </p:sld>
 </file>
 
-<file path=ppt/slides/slide3.xml><?xml version="1.0" encoding="utf-8"?>
+<file path=ppt/slides/slide4.xml><?xml version="1.0" encoding="utf-8"?>
 <p:sld xmlns:a="http://schemas.openxmlformats.org/drawingml/2006/main" xmlns:r="http://schemas.openxmlformats.org/officeDocument/2006/relationships" xmlns:p="http://schemas.openxmlformats.org/presentationml/2006/main">
   <p:cSld>
     <p:spTree>
@@ -2262,7 +2695,7 @@
 </p:sld>
 </file>
 
-<file path=ppt/slides/slide4.xml><?xml version="1.0" encoding="utf-8"?>
+<file path=ppt/slides/slide5.xml><?xml version="1.0" encoding="utf-8"?>
 <p:sld xmlns:a="http://schemas.openxmlformats.org/drawingml/2006/main" xmlns:r="http://schemas.openxmlformats.org/officeDocument/2006/relationships" xmlns:p="http://schemas.openxmlformats.org/presentationml/2006/main">
   <p:cSld>
     <p:spTree>
@@ -2604,7 +3037,7 @@
 </p:sld>
 </file>
 
-<file path=ppt/slides/slide5.xml><?xml version="1.0" encoding="utf-8"?>
+<file path=ppt/slides/slide6.xml><?xml version="1.0" encoding="utf-8"?>
 <p:sld xmlns:a="http://schemas.openxmlformats.org/drawingml/2006/main" xmlns:r="http://schemas.openxmlformats.org/officeDocument/2006/relationships" xmlns:p="http://schemas.openxmlformats.org/presentationml/2006/main">
   <p:cSld>
     <p:spTree>
@@ -4431,7 +4864,7 @@
 </p:sld>
 </file>
 
-<file path=ppt/slides/slide6.xml><?xml version="1.0" encoding="utf-8"?>
+<file path=ppt/slides/slide7.xml><?xml version="1.0" encoding="utf-8"?>
 <p:sld xmlns:a="http://schemas.openxmlformats.org/drawingml/2006/main" xmlns:r="http://schemas.openxmlformats.org/officeDocument/2006/relationships" xmlns:p="http://schemas.openxmlformats.org/presentationml/2006/main">
   <p:cSld>
     <p:spTree>
@@ -4541,7 +4974,7 @@
 </p:sld>
 </file>
 
-<file path=ppt/slides/slide7.xml><?xml version="1.0" encoding="utf-8"?>
+<file path=ppt/slides/slide8.xml><?xml version="1.0" encoding="utf-8"?>
 <p:sld xmlns:a="http://schemas.openxmlformats.org/drawingml/2006/main" xmlns:r="http://schemas.openxmlformats.org/officeDocument/2006/relationships" xmlns:p="http://schemas.openxmlformats.org/presentationml/2006/main">
   <p:cSld>
     <p:spTree>
@@ -4718,7 +5151,7 @@
 </p:sld>
 </file>
 
-<file path=ppt/slides/slide8.xml><?xml version="1.0" encoding="utf-8"?>
+<file path=ppt/slides/slide9.xml><?xml version="1.0" encoding="utf-8"?>
 <p:sld xmlns:a="http://schemas.openxmlformats.org/drawingml/2006/main" xmlns:r="http://schemas.openxmlformats.org/officeDocument/2006/relationships" xmlns:p="http://schemas.openxmlformats.org/presentationml/2006/main">
   <p:cSld>
     <p:spTree>

</xml_diff>

<commit_message>
updating changelog, building new release
</commit_message>
<xml_diff>
--- a/Documentation/User Manual Source/Release Notes Vecto4.x.pptx
+++ b/Documentation/User Manual Source/Release Notes Vecto4.x.pptx
@@ -5,20 +5,21 @@
     <p:sldMasterId id="2147483661" r:id="rId1"/>
   </p:sldMasterIdLst>
   <p:notesMasterIdLst>
-    <p:notesMasterId r:id="rId13"/>
+    <p:notesMasterId r:id="rId14"/>
   </p:notesMasterIdLst>
   <p:sldIdLst>
     <p:sldId id="256" r:id="rId2"/>
     <p:sldId id="1322" r:id="rId3"/>
-    <p:sldId id="258" r:id="rId4"/>
-    <p:sldId id="1321" r:id="rId5"/>
-    <p:sldId id="1320" r:id="rId6"/>
-    <p:sldId id="1289" r:id="rId7"/>
-    <p:sldId id="1314" r:id="rId8"/>
-    <p:sldId id="1318" r:id="rId9"/>
-    <p:sldId id="1315" r:id="rId10"/>
-    <p:sldId id="1319" r:id="rId11"/>
-    <p:sldId id="1316" r:id="rId12"/>
+    <p:sldId id="1323" r:id="rId4"/>
+    <p:sldId id="258" r:id="rId5"/>
+    <p:sldId id="1321" r:id="rId6"/>
+    <p:sldId id="1320" r:id="rId7"/>
+    <p:sldId id="1289" r:id="rId8"/>
+    <p:sldId id="1314" r:id="rId9"/>
+    <p:sldId id="1318" r:id="rId10"/>
+    <p:sldId id="1315" r:id="rId11"/>
+    <p:sldId id="1319" r:id="rId12"/>
+    <p:sldId id="1316" r:id="rId13"/>
   </p:sldIdLst>
   <p:sldSz cx="9144000" cy="6858000" type="screen4x3"/>
   <p:notesSz cx="7772400" cy="10058400"/>
@@ -124,6 +125,7 @@
           <p14:sldIdLst>
             <p14:sldId id="256"/>
             <p14:sldId id="1322"/>
+            <p14:sldId id="1323"/>
             <p14:sldId id="258"/>
             <p14:sldId id="1321"/>
             <p14:sldId id="1320"/>
@@ -226,7 +228,7 @@
           <a:p>
             <a:fld id="{390E69D5-8A05-43AD-B5FD-86D96081B052}" type="datetimeFigureOut">
               <a:rPr lang="de-AT" smtClean="0"/>
-              <a:t>18.12.2023</a:t>
+              <a:t>20.12.2023</a:t>
             </a:fld>
             <a:endParaRPr lang="de-AT"/>
           </a:p>
@@ -1956,6 +1958,116 @@
       </p:grpSpPr>
       <p:sp>
         <p:nvSpPr>
+          <p:cNvPr id="6" name="Inhaltsplatzhalter 5"/>
+          <p:cNvSpPr>
+            <a:spLocks noGrp="1"/>
+          </p:cNvSpPr>
+          <p:nvPr>
+            <p:ph idx="1"/>
+          </p:nvPr>
+        </p:nvSpPr>
+        <p:spPr>
+          <a:xfrm>
+            <a:off x="588206" y="1300092"/>
+            <a:ext cx="8394645" cy="4195735"/>
+          </a:xfrm>
+        </p:spPr>
+        <p:txBody>
+          <a:bodyPr>
+            <a:normAutofit/>
+          </a:bodyPr>
+          <a:lstStyle/>
+          <a:p>
+            <a:pPr>
+              <a:spcBef>
+                <a:spcPts val="1200"/>
+              </a:spcBef>
+            </a:pPr>
+            <a:r>
+              <a:rPr lang="en-US" sz="1800" dirty="0"/>
+              <a:t>XML Job Files &lt; v2.4 are no longer supported</a:t>
+            </a:r>
+          </a:p>
+          <a:p>
+            <a:pPr>
+              <a:spcBef>
+                <a:spcPts val="1200"/>
+              </a:spcBef>
+            </a:pPr>
+            <a:r>
+              <a:rPr lang="en-US" sz="1800" dirty="0"/>
+              <a:t>Dropped support for .NET Framework 4.5 (EOL 04/2022)</a:t>
+            </a:r>
+          </a:p>
+          <a:p>
+            <a:pPr>
+              <a:spcBef>
+                <a:spcPts val="1200"/>
+              </a:spcBef>
+            </a:pPr>
+            <a:endParaRPr lang="en-US" sz="1800" dirty="0"/>
+          </a:p>
+        </p:txBody>
+      </p:sp>
+      <p:sp>
+        <p:nvSpPr>
+          <p:cNvPr id="5" name="Titel 4"/>
+          <p:cNvSpPr>
+            <a:spLocks noGrp="1"/>
+          </p:cNvSpPr>
+          <p:nvPr>
+            <p:ph type="title"/>
+          </p:nvPr>
+        </p:nvSpPr>
+        <p:spPr>
+          <a:xfrm>
+            <a:off x="588206" y="453542"/>
+            <a:ext cx="8229240" cy="478905"/>
+          </a:xfrm>
+        </p:spPr>
+        <p:txBody>
+          <a:bodyPr/>
+          <a:lstStyle/>
+          <a:p>
+            <a:r>
+              <a:rPr lang="en-GB" dirty="0"/>
+              <a:t>Changes</a:t>
+            </a:r>
+          </a:p>
+        </p:txBody>
+      </p:sp>
+    </p:spTree>
+    <p:extLst>
+      <p:ext uri="{BB962C8B-B14F-4D97-AF65-F5344CB8AC3E}">
+        <p14:creationId xmlns:p14="http://schemas.microsoft.com/office/powerpoint/2010/main" val="3711980566"/>
+      </p:ext>
+    </p:extLst>
+  </p:cSld>
+  <p:clrMapOvr>
+    <a:masterClrMapping/>
+  </p:clrMapOvr>
+</p:sld>
+</file>
+
+<file path=ppt/slides/slide11.xml><?xml version="1.0" encoding="utf-8"?>
+<p:sld xmlns:a="http://schemas.openxmlformats.org/drawingml/2006/main" xmlns:r="http://schemas.openxmlformats.org/officeDocument/2006/relationships" xmlns:p="http://schemas.openxmlformats.org/presentationml/2006/main">
+  <p:cSld>
+    <p:spTree>
+      <p:nvGrpSpPr>
+        <p:cNvPr id="1" name=""/>
+        <p:cNvGrpSpPr/>
+        <p:nvPr/>
+      </p:nvGrpSpPr>
+      <p:grpSpPr>
+        <a:xfrm>
+          <a:off x="0" y="0"/>
+          <a:ext cx="0" cy="0"/>
+          <a:chOff x="0" y="0"/>
+          <a:chExt cx="0" cy="0"/>
+        </a:xfrm>
+      </p:grpSpPr>
+      <p:sp>
+        <p:nvSpPr>
           <p:cNvPr id="5" name="Titel 4"/>
           <p:cNvSpPr>
             <a:spLocks noGrp="1"/>
@@ -2114,7 +2226,7 @@
 </p:sld>
 </file>
 
-<file path=ppt/slides/slide11.xml><?xml version="1.0" encoding="utf-8"?>
+<file path=ppt/slides/slide12.xml><?xml version="1.0" encoding="utf-8"?>
 <p:sld xmlns:a="http://schemas.openxmlformats.org/drawingml/2006/main" xmlns:r="http://schemas.openxmlformats.org/officeDocument/2006/relationships" xmlns:p="http://schemas.openxmlformats.org/presentationml/2006/main">
   <p:cSld>
     <p:spTree>
@@ -2672,7 +2784,7 @@
                 </a:solidFill>
                 <a:latin typeface="Arial"/>
               </a:rPr>
-              <a:t>Vecto 4.0.2.3273 OFFICIAL RELEASE</a:t>
+              <a:t>Vecto 4.0.2.3275 OFFICIAL RELEASE</a:t>
             </a:r>
             <a:br>
               <a:rPr sz="2400" dirty="0"/>
@@ -2681,7 +2793,7 @@
               <a:rPr lang="en-US" sz="1600" spc="-1" dirty="0">
                 <a:latin typeface="Arial"/>
               </a:rPr>
-              <a:t>18.12.2023</a:t>
+              <a:t>20.12.2023</a:t>
             </a:r>
             <a:endParaRPr lang="en-US" sz="1600" b="0" strike="noStrike" spc="-1" dirty="0">
               <a:latin typeface="Arial"/>
@@ -2701,8 +2813,8 @@
         </p:nvSpPr>
         <p:spPr>
           <a:xfrm>
-            <a:off x="323640" y="1268640"/>
-            <a:ext cx="8496360" cy="4823640"/>
+            <a:off x="323640" y="1639018"/>
+            <a:ext cx="8496360" cy="4453261"/>
           </a:xfrm>
           <a:prstGeom prst="rect">
             <a:avLst/>
@@ -2740,7 +2852,7 @@
                   <a:srgbClr val="000000"/>
                 </a:solidFill>
               </a:rPr>
-              <a:t>Bugfixes (1/2)</a:t>
+              <a:t>Hotfix</a:t>
             </a:r>
           </a:p>
           <a:p>
@@ -2766,23 +2878,7 @@
                   <a:srgbClr val="000000"/>
                 </a:solidFill>
               </a:rPr>
-              <a:t>CodeEU-94: </a:t>
-            </a:r>
-            <a:r>
-              <a:rPr lang="en-US" sz="1200" spc="-1" dirty="0" err="1">
-                <a:solidFill>
-                  <a:srgbClr val="000000"/>
-                </a:solidFill>
-              </a:rPr>
-              <a:t>DistanceRun</a:t>
-            </a:r>
-            <a:r>
-              <a:rPr lang="en-US" sz="1200" spc="-1" dirty="0">
-                <a:solidFill>
-                  <a:srgbClr val="000000"/>
-                </a:solidFill>
-              </a:rPr>
-              <a:t> got an unexpected response</a:t>
+              <a:t>CodeEU-273, CodeEU-274: Changes in the AMT shift strategy regarding idling speed caused simulation aborts</a:t>
             </a:r>
           </a:p>
           <a:p>
@@ -2808,701 +2904,8 @@
                   <a:srgbClr val="000000"/>
                 </a:solidFill>
               </a:rPr>
-              <a:t>CodeEU-153: </a:t>
-            </a:r>
-            <a:r>
-              <a:rPr lang="en-US" sz="1200" spc="-1" dirty="0" err="1">
-                <a:solidFill>
-                  <a:srgbClr val="000000"/>
-                </a:solidFill>
-              </a:rPr>
-              <a:t>DrivingActionAccelerate</a:t>
-            </a:r>
-            <a:r>
-              <a:rPr lang="en-US" sz="1200" spc="-1" dirty="0">
-                <a:solidFill>
-                  <a:srgbClr val="000000"/>
-                </a:solidFill>
-              </a:rPr>
-              <a:t>: Failed to find operating point after Overload</a:t>
-            </a:r>
-          </a:p>
-          <a:p>
-            <a:pPr marL="800280" lvl="1" indent="-343080">
-              <a:lnSpc>
-                <a:spcPct val="100000"/>
-              </a:lnSpc>
-              <a:spcBef>
-                <a:spcPts val="320"/>
-              </a:spcBef>
-              <a:buClr>
-                <a:srgbClr val="000000"/>
-              </a:buClr>
-              <a:buFont typeface="Symbol"/>
-              <a:buChar char=""/>
-              <a:tabLst>
-                <a:tab pos="1886040" algn="l"/>
-              </a:tabLst>
-            </a:pPr>
-            <a:r>
-              <a:rPr lang="en-US" sz="1200" spc="-1" dirty="0">
-                <a:solidFill>
-                  <a:srgbClr val="000000"/>
-                </a:solidFill>
-              </a:rPr>
-              <a:t>CodeEU-158: Urban </a:t>
-            </a:r>
-            <a:r>
-              <a:rPr lang="en-US" sz="1200" spc="-1" dirty="0" err="1">
-                <a:solidFill>
-                  <a:srgbClr val="000000"/>
-                </a:solidFill>
-              </a:rPr>
-              <a:t>RefLoad</a:t>
-            </a:r>
-            <a:r>
-              <a:rPr lang="en-US" sz="1200" spc="-1" dirty="0">
-                <a:solidFill>
-                  <a:srgbClr val="000000"/>
-                </a:solidFill>
-              </a:rPr>
-              <a:t> </a:t>
-            </a:r>
-            <a:r>
-              <a:rPr lang="en-US" sz="1200" spc="-1" dirty="0" err="1">
-                <a:solidFill>
-                  <a:srgbClr val="000000"/>
-                </a:solidFill>
-              </a:rPr>
-              <a:t>DrivingActionAccelerate</a:t>
-            </a:r>
-            <a:r>
-              <a:rPr lang="en-US" sz="1200" spc="-1" dirty="0">
-                <a:solidFill>
-                  <a:srgbClr val="000000"/>
-                </a:solidFill>
-              </a:rPr>
-              <a:t>: Failed to find operating point (IEPC </a:t>
-            </a:r>
-            <a:r>
-              <a:rPr lang="en-US" sz="1200" spc="-1" dirty="0" err="1">
-                <a:solidFill>
-                  <a:srgbClr val="000000"/>
-                </a:solidFill>
-              </a:rPr>
-              <a:t>Wheelhub</a:t>
-            </a:r>
-            <a:r>
-              <a:rPr lang="en-US" sz="1200" spc="-1" dirty="0">
-                <a:solidFill>
-                  <a:srgbClr val="000000"/>
-                </a:solidFill>
-              </a:rPr>
-              <a:t> 1 measured)</a:t>
-            </a:r>
-          </a:p>
-          <a:p>
-            <a:pPr marL="800280" lvl="1" indent="-343080">
-              <a:lnSpc>
-                <a:spcPct val="100000"/>
-              </a:lnSpc>
-              <a:spcBef>
-                <a:spcPts val="320"/>
-              </a:spcBef>
-              <a:buClr>
-                <a:srgbClr val="000000"/>
-              </a:buClr>
-              <a:buFont typeface="Symbol"/>
-              <a:buChar char=""/>
-              <a:tabLst>
-                <a:tab pos="1886040" algn="l"/>
-              </a:tabLst>
-            </a:pPr>
-            <a:r>
-              <a:rPr lang="en-US" sz="1200" spc="-1" dirty="0">
-                <a:solidFill>
-                  <a:srgbClr val="000000"/>
-                </a:solidFill>
-              </a:rPr>
-              <a:t>CodeEU-168: Vecto Declaration Simulation with P1-Hybrid shows multiple errors - Simulation Aborts!</a:t>
-            </a:r>
-          </a:p>
-          <a:p>
-            <a:pPr marL="800280" lvl="1" indent="-343080">
-              <a:lnSpc>
-                <a:spcPct val="100000"/>
-              </a:lnSpc>
-              <a:spcBef>
-                <a:spcPts val="320"/>
-              </a:spcBef>
-              <a:buClr>
-                <a:srgbClr val="000000"/>
-              </a:buClr>
-              <a:buFont typeface="Symbol"/>
-              <a:buChar char=""/>
-              <a:tabLst>
-                <a:tab pos="1886040" algn="l"/>
-              </a:tabLst>
-            </a:pPr>
-            <a:r>
-              <a:rPr lang="en-US" sz="1200" spc="-1" dirty="0">
-                <a:solidFill>
-                  <a:srgbClr val="000000"/>
-                </a:solidFill>
-              </a:rPr>
-              <a:t>CodeEU-191: Boosting limits HEV </a:t>
-            </a:r>
-            <a:r>
-              <a:rPr lang="en-US" sz="1200" spc="-1" dirty="0" err="1">
-                <a:solidFill>
-                  <a:srgbClr val="000000"/>
-                </a:solidFill>
-              </a:rPr>
-              <a:t>ovc</a:t>
-            </a:r>
-            <a:r>
-              <a:rPr lang="en-US" sz="1200" spc="-1" dirty="0">
-                <a:solidFill>
-                  <a:srgbClr val="000000"/>
-                </a:solidFill>
-              </a:rPr>
-              <a:t> are not working</a:t>
-            </a:r>
-          </a:p>
-          <a:p>
-            <a:pPr marL="800280" lvl="1" indent="-343080">
-              <a:lnSpc>
-                <a:spcPct val="100000"/>
-              </a:lnSpc>
-              <a:spcBef>
-                <a:spcPts val="320"/>
-              </a:spcBef>
-              <a:buClr>
-                <a:srgbClr val="000000"/>
-              </a:buClr>
-              <a:buFont typeface="Symbol"/>
-              <a:buChar char=""/>
-              <a:tabLst>
-                <a:tab pos="1886040" algn="l"/>
-              </a:tabLst>
-            </a:pPr>
-            <a:r>
-              <a:rPr lang="en-US" sz="1200" spc="-1" dirty="0">
-                <a:solidFill>
-                  <a:srgbClr val="000000"/>
-                </a:solidFill>
-              </a:rPr>
-              <a:t>CodeEU-202: EMS Standard Values: Continuous/Overload Torque 0 Nm</a:t>
-            </a:r>
-          </a:p>
-          <a:p>
-            <a:pPr marL="800280" lvl="1" indent="-343080">
-              <a:lnSpc>
-                <a:spcPct val="100000"/>
-              </a:lnSpc>
-              <a:spcBef>
-                <a:spcPts val="320"/>
-              </a:spcBef>
-              <a:buClr>
-                <a:srgbClr val="000000"/>
-              </a:buClr>
-              <a:buFont typeface="Symbol"/>
-              <a:buChar char=""/>
-              <a:tabLst>
-                <a:tab pos="1886040" algn="l"/>
-              </a:tabLst>
-            </a:pPr>
-            <a:r>
-              <a:rPr lang="en-US" sz="1200" spc="-1" dirty="0">
-                <a:solidFill>
-                  <a:srgbClr val="000000"/>
-                </a:solidFill>
-              </a:rPr>
-              <a:t>CodeEU-203: </a:t>
-            </a:r>
-            <a:r>
-              <a:rPr lang="en-US" sz="1200" spc="-1" dirty="0" err="1">
-                <a:solidFill>
-                  <a:srgbClr val="000000"/>
-                </a:solidFill>
-              </a:rPr>
-              <a:t>HybridStrategy</a:t>
-            </a:r>
-            <a:r>
-              <a:rPr lang="en-US" sz="1200" spc="-1" dirty="0">
-                <a:solidFill>
-                  <a:srgbClr val="000000"/>
-                </a:solidFill>
-              </a:rPr>
-              <a:t> error for IHPC type 1 hybrid lorry</a:t>
-            </a:r>
-          </a:p>
-          <a:p>
-            <a:pPr marL="800280" lvl="1" indent="-343080">
-              <a:lnSpc>
-                <a:spcPct val="100000"/>
-              </a:lnSpc>
-              <a:spcBef>
-                <a:spcPts val="320"/>
-              </a:spcBef>
-              <a:buClr>
-                <a:srgbClr val="000000"/>
-              </a:buClr>
-              <a:buFont typeface="Symbol"/>
-              <a:buChar char=""/>
-              <a:tabLst>
-                <a:tab pos="1886040" algn="l"/>
-              </a:tabLst>
-            </a:pPr>
-            <a:r>
-              <a:rPr lang="en-US" sz="1200" spc="-1" dirty="0">
-                <a:solidFill>
-                  <a:srgbClr val="000000"/>
-                </a:solidFill>
-              </a:rPr>
-              <a:t>CodeEU-206: VTP + PEMS test done by Renault Trucks France - VECTO tool errors most probably linked to automatic gearbox (with torque converter)</a:t>
-            </a:r>
-          </a:p>
-          <a:p>
-            <a:pPr marL="800280" lvl="1" indent="-343080">
-              <a:lnSpc>
-                <a:spcPct val="100000"/>
-              </a:lnSpc>
-              <a:spcBef>
-                <a:spcPts val="320"/>
-              </a:spcBef>
-              <a:buClr>
-                <a:srgbClr val="000000"/>
-              </a:buClr>
-              <a:buFont typeface="Symbol"/>
-              <a:buChar char=""/>
-              <a:tabLst>
-                <a:tab pos="1886040" algn="l"/>
-              </a:tabLst>
-            </a:pPr>
-            <a:r>
-              <a:rPr lang="en-US" sz="1200" spc="-1" dirty="0">
-                <a:solidFill>
-                  <a:srgbClr val="000000"/>
-                </a:solidFill>
-              </a:rPr>
-              <a:t>CodeEU-211: Hybrid P1 configurations with errors</a:t>
-            </a:r>
-          </a:p>
-          <a:p>
-            <a:pPr marL="800280" lvl="1" indent="-343080">
-              <a:lnSpc>
-                <a:spcPct val="100000"/>
-              </a:lnSpc>
-              <a:spcBef>
-                <a:spcPts val="320"/>
-              </a:spcBef>
-              <a:buClr>
-                <a:srgbClr val="000000"/>
-              </a:buClr>
-              <a:buFont typeface="Symbol"/>
-              <a:buChar char=""/>
-              <a:tabLst>
-                <a:tab pos="1886040" algn="l"/>
-              </a:tabLst>
-            </a:pPr>
-            <a:r>
-              <a:rPr lang="en-US" sz="1200" spc="-1" dirty="0">
-                <a:solidFill>
-                  <a:srgbClr val="000000"/>
-                </a:solidFill>
-              </a:rPr>
-              <a:t>CodeEU-215: </a:t>
-            </a:r>
-            <a:r>
-              <a:rPr lang="en-US" sz="1200" spc="-1" dirty="0" err="1">
-                <a:solidFill>
-                  <a:srgbClr val="000000"/>
-                </a:solidFill>
-              </a:rPr>
-              <a:t>MultiStep</a:t>
-            </a:r>
-            <a:r>
-              <a:rPr lang="en-US" sz="1200" spc="-1" dirty="0">
-                <a:solidFill>
-                  <a:srgbClr val="000000"/>
-                </a:solidFill>
-              </a:rPr>
-              <a:t> tool help</a:t>
-            </a:r>
-          </a:p>
-          <a:p>
-            <a:pPr marL="800280" lvl="1" indent="-343080">
-              <a:lnSpc>
-                <a:spcPct val="100000"/>
-              </a:lnSpc>
-              <a:spcBef>
-                <a:spcPts val="320"/>
-              </a:spcBef>
-              <a:buClr>
-                <a:srgbClr val="000000"/>
-              </a:buClr>
-              <a:buFont typeface="Symbol"/>
-              <a:buChar char=""/>
-              <a:tabLst>
-                <a:tab pos="1886040" algn="l"/>
-              </a:tabLst>
-            </a:pPr>
-            <a:r>
-              <a:rPr lang="en-US" sz="1200" spc="-1" dirty="0">
-                <a:solidFill>
-                  <a:srgbClr val="000000"/>
-                </a:solidFill>
-              </a:rPr>
-              <a:t>CodeEU-216: </a:t>
-            </a:r>
-            <a:r>
-              <a:rPr lang="en-US" sz="1200" spc="-1" dirty="0" err="1">
-                <a:solidFill>
-                  <a:srgbClr val="000000"/>
-                </a:solidFill>
-              </a:rPr>
-              <a:t>NrOfGears</a:t>
-            </a:r>
-            <a:r>
-              <a:rPr lang="en-US" sz="1200" spc="-1" dirty="0">
-                <a:solidFill>
-                  <a:srgbClr val="000000"/>
-                </a:solidFill>
-              </a:rPr>
-              <a:t> in CIF is 1 for IEPC no matter how many gears it has</a:t>
-            </a:r>
-          </a:p>
-          <a:p>
-            <a:pPr marL="800280" lvl="1" indent="-343080">
-              <a:lnSpc>
-                <a:spcPct val="100000"/>
-              </a:lnSpc>
-              <a:spcBef>
-                <a:spcPts val="320"/>
-              </a:spcBef>
-              <a:buClr>
-                <a:srgbClr val="000000"/>
-              </a:buClr>
-              <a:buFont typeface="Symbol"/>
-              <a:buChar char=""/>
-              <a:tabLst>
-                <a:tab pos="1886040" algn="l"/>
-              </a:tabLst>
-            </a:pPr>
-            <a:r>
-              <a:rPr lang="en-US" sz="1200" spc="-1" dirty="0">
-                <a:solidFill>
-                  <a:srgbClr val="000000"/>
-                </a:solidFill>
-              </a:rPr>
-              <a:t>CodeEU-220: Error manual transmission 2. gear</a:t>
-            </a:r>
-          </a:p>
-          <a:p>
-            <a:pPr marL="800280" lvl="1" indent="-343080">
-              <a:lnSpc>
-                <a:spcPct val="100000"/>
-              </a:lnSpc>
-              <a:spcBef>
-                <a:spcPts val="320"/>
-              </a:spcBef>
-              <a:buClr>
-                <a:srgbClr val="000000"/>
-              </a:buClr>
-              <a:buFont typeface="Symbol"/>
-              <a:buChar char=""/>
-              <a:tabLst>
-                <a:tab pos="1886040" algn="l"/>
-              </a:tabLst>
-            </a:pPr>
-            <a:r>
-              <a:rPr lang="en-US" sz="1200" spc="-1" dirty="0">
-                <a:solidFill>
-                  <a:srgbClr val="000000"/>
-                </a:solidFill>
-              </a:rPr>
-              <a:t>CodeEU-224: Issue with PEV complete vehicle simulation (Vecto </a:t>
-            </a:r>
-            <a:r>
-              <a:rPr lang="en-US" sz="1200" spc="-1" dirty="0" err="1">
-                <a:solidFill>
-                  <a:srgbClr val="000000"/>
-                </a:solidFill>
-              </a:rPr>
-              <a:t>MultiStage</a:t>
-            </a:r>
-            <a:r>
-              <a:rPr lang="en-US" sz="1200" spc="-1" dirty="0">
-                <a:solidFill>
-                  <a:srgbClr val="000000"/>
-                </a:solidFill>
-              </a:rPr>
-              <a:t>)</a:t>
-            </a:r>
-          </a:p>
-          <a:p>
-            <a:pPr marL="800280" lvl="1" indent="-343080">
-              <a:lnSpc>
-                <a:spcPct val="100000"/>
-              </a:lnSpc>
-              <a:spcBef>
-                <a:spcPts val="320"/>
-              </a:spcBef>
-              <a:buClr>
-                <a:srgbClr val="000000"/>
-              </a:buClr>
-              <a:buFont typeface="Symbol"/>
-              <a:buChar char=""/>
-              <a:tabLst>
-                <a:tab pos="1886040" algn="l"/>
-              </a:tabLst>
-            </a:pPr>
-            <a:r>
-              <a:rPr lang="en-US" sz="1200" spc="-1" dirty="0">
-                <a:solidFill>
-                  <a:srgbClr val="000000"/>
-                </a:solidFill>
-              </a:rPr>
-              <a:t>CodeEU-231: IVECO CONFIDENTIAL : hybrid buses completed simulation aborted</a:t>
-            </a:r>
-          </a:p>
-          <a:p>
-            <a:pPr marL="800280" lvl="1" indent="-343080">
-              <a:lnSpc>
-                <a:spcPct val="100000"/>
-              </a:lnSpc>
-              <a:spcBef>
-                <a:spcPts val="320"/>
-              </a:spcBef>
-              <a:buClr>
-                <a:srgbClr val="000000"/>
-              </a:buClr>
-              <a:buFont typeface="Symbol"/>
-              <a:buChar char=""/>
-              <a:tabLst>
-                <a:tab pos="1886040" algn="l"/>
-              </a:tabLst>
-            </a:pPr>
-            <a:r>
-              <a:rPr lang="en-US" sz="1200" spc="-1" dirty="0">
-                <a:solidFill>
-                  <a:srgbClr val="000000"/>
-                </a:solidFill>
-              </a:rPr>
-              <a:t>CodeEU-234: Error Conventional Lorry Gear: 1C </a:t>
-            </a:r>
-            <a:r>
-              <a:rPr lang="en-US" sz="1200" spc="-1" dirty="0" err="1">
-                <a:solidFill>
-                  <a:srgbClr val="000000"/>
-                </a:solidFill>
-              </a:rPr>
-              <a:t>DistanceRun</a:t>
-            </a:r>
-            <a:r>
-              <a:rPr lang="en-US" sz="1200" spc="-1" dirty="0">
-                <a:solidFill>
-                  <a:srgbClr val="000000"/>
-                </a:solidFill>
-              </a:rPr>
-              <a:t> got an unexpected response</a:t>
-            </a:r>
-          </a:p>
-          <a:p>
-            <a:pPr marL="800280" lvl="1" indent="-343080">
-              <a:lnSpc>
-                <a:spcPct val="100000"/>
-              </a:lnSpc>
-              <a:spcBef>
-                <a:spcPts val="320"/>
-              </a:spcBef>
-              <a:buClr>
-                <a:srgbClr val="000000"/>
-              </a:buClr>
-              <a:buFont typeface="Symbol"/>
-              <a:buChar char=""/>
-              <a:tabLst>
-                <a:tab pos="1886040" algn="l"/>
-              </a:tabLst>
-            </a:pPr>
-            <a:r>
-              <a:rPr lang="en-US" sz="1200" spc="-1" dirty="0">
-                <a:solidFill>
-                  <a:srgbClr val="000000"/>
-                </a:solidFill>
-              </a:rPr>
-              <a:t>CodeEU-235: </a:t>
-            </a:r>
-            <a:r>
-              <a:rPr lang="en-US" sz="1200" spc="-1" dirty="0" err="1">
-                <a:solidFill>
-                  <a:srgbClr val="000000"/>
-                </a:solidFill>
-              </a:rPr>
-              <a:t>Tyre</a:t>
-            </a:r>
-            <a:r>
-              <a:rPr lang="en-US" sz="1200" spc="-1" dirty="0">
-                <a:solidFill>
-                  <a:srgbClr val="000000"/>
-                </a:solidFill>
-              </a:rPr>
-              <a:t> error calculation buses "invalid </a:t>
-            </a:r>
-            <a:r>
-              <a:rPr lang="en-US" sz="1200" spc="-1" dirty="0" err="1">
-                <a:solidFill>
-                  <a:srgbClr val="000000"/>
-                </a:solidFill>
-              </a:rPr>
-              <a:t>xsi:type</a:t>
-            </a:r>
-            <a:r>
-              <a:rPr lang="en-US" sz="1200" spc="-1" dirty="0">
-                <a:solidFill>
-                  <a:srgbClr val="000000"/>
-                </a:solidFill>
-              </a:rPr>
-              <a:t> '</a:t>
-            </a:r>
-            <a:r>
-              <a:rPr lang="en-US" sz="1200" spc="-1" dirty="0" err="1">
-                <a:solidFill>
-                  <a:srgbClr val="000000"/>
-                </a:solidFill>
-              </a:rPr>
-              <a:t>TyreDataDeclarationType</a:t>
-            </a:r>
-            <a:r>
-              <a:rPr lang="en-US" sz="1200" spc="-1" dirty="0">
-                <a:solidFill>
-                  <a:srgbClr val="000000"/>
-                </a:solidFill>
-              </a:rPr>
-              <a:t>'"</a:t>
-            </a:r>
-          </a:p>
-          <a:p>
-            <a:pPr marL="800280" lvl="1" indent="-343080">
-              <a:lnSpc>
-                <a:spcPct val="100000"/>
-              </a:lnSpc>
-              <a:spcBef>
-                <a:spcPts val="320"/>
-              </a:spcBef>
-              <a:buClr>
-                <a:srgbClr val="000000"/>
-              </a:buClr>
-              <a:buFont typeface="Symbol"/>
-              <a:buChar char=""/>
-              <a:tabLst>
-                <a:tab pos="1886040" algn="l"/>
-              </a:tabLst>
-            </a:pPr>
-            <a:r>
-              <a:rPr lang="en-US" sz="1200" spc="-1" dirty="0">
-                <a:solidFill>
-                  <a:srgbClr val="000000"/>
-                </a:solidFill>
-              </a:rPr>
-              <a:t>CodeEU-238: Bus VIF files not valid in Multistep VECTO</a:t>
-            </a:r>
-          </a:p>
-          <a:p>
-            <a:pPr marL="800280" lvl="1" indent="-343080">
-              <a:lnSpc>
-                <a:spcPct val="100000"/>
-              </a:lnSpc>
-              <a:spcBef>
-                <a:spcPts val="320"/>
-              </a:spcBef>
-              <a:buClr>
-                <a:srgbClr val="000000"/>
-              </a:buClr>
-              <a:buFont typeface="Symbol"/>
-              <a:buChar char=""/>
-              <a:tabLst>
-                <a:tab pos="1886040" algn="l"/>
-              </a:tabLst>
-            </a:pPr>
-            <a:r>
-              <a:rPr lang="en-US" sz="1200" spc="-1" dirty="0">
-                <a:solidFill>
-                  <a:srgbClr val="000000"/>
-                </a:solidFill>
-              </a:rPr>
-              <a:t>CodeEU-243: Simulation aborted: Gear 5 </a:t>
-            </a:r>
-            <a:r>
-              <a:rPr lang="en-US" sz="1200" spc="-1" dirty="0" err="1">
-                <a:solidFill>
-                  <a:srgbClr val="000000"/>
-                </a:solidFill>
-              </a:rPr>
-              <a:t>Lossmap</a:t>
-            </a:r>
-            <a:r>
-              <a:rPr lang="en-US" sz="1200" spc="-1" dirty="0">
-                <a:solidFill>
-                  <a:srgbClr val="000000"/>
-                </a:solidFill>
-              </a:rPr>
-              <a:t> not </a:t>
-            </a:r>
-            <a:r>
-              <a:rPr lang="en-US" sz="1200" spc="-1" dirty="0" err="1">
-                <a:solidFill>
-                  <a:srgbClr val="000000"/>
-                </a:solidFill>
-              </a:rPr>
-              <a:t>sufficiant</a:t>
-            </a:r>
-            <a:endParaRPr lang="en-US" sz="1200" spc="-1" dirty="0">
-              <a:solidFill>
-                <a:srgbClr val="000000"/>
-              </a:solidFill>
-            </a:endParaRPr>
-          </a:p>
-          <a:p>
-            <a:pPr marL="800280" lvl="1" indent="-343080">
-              <a:lnSpc>
-                <a:spcPct val="100000"/>
-              </a:lnSpc>
-              <a:spcBef>
-                <a:spcPts val="320"/>
-              </a:spcBef>
-              <a:buClr>
-                <a:srgbClr val="000000"/>
-              </a:buClr>
-              <a:buFont typeface="Symbol"/>
-              <a:buChar char=""/>
-              <a:tabLst>
-                <a:tab pos="1886040" algn="l"/>
-              </a:tabLst>
-            </a:pPr>
-            <a:r>
-              <a:rPr lang="en-US" sz="1200" spc="-1" dirty="0">
-                <a:solidFill>
-                  <a:srgbClr val="000000"/>
-                </a:solidFill>
-              </a:rPr>
-              <a:t>CodeEU-244: Signature validation fails for old (prior to v4) Manufacturer reports</a:t>
-            </a:r>
-          </a:p>
-          <a:p>
-            <a:pPr>
-              <a:lnSpc>
-                <a:spcPct val="100000"/>
-              </a:lnSpc>
-              <a:buNone/>
-              <a:tabLst>
-                <a:tab pos="1886040" algn="l"/>
-              </a:tabLst>
-            </a:pPr>
-            <a:endParaRPr lang="en-US" sz="1400" b="0" strike="noStrike" spc="-1" dirty="0">
-              <a:latin typeface="Arial"/>
-            </a:endParaRPr>
+              <a:t>CodeEU-260: regression fix handling overload buffer</a:t>
+            </a:r>
           </a:p>
         </p:txBody>
       </p:sp>
@@ -3646,7 +3049,7 @@
                   <a:srgbClr val="000000"/>
                 </a:solidFill>
               </a:rPr>
-              <a:t>Bugfixes (2/2)</a:t>
+              <a:t>Bugfixes (1/2)</a:t>
             </a:r>
           </a:p>
           <a:p>
@@ -3672,7 +3075,7 @@
                   <a:srgbClr val="000000"/>
                 </a:solidFill>
               </a:rPr>
-              <a:t>CodeEU-249: Fix handling gear torque limits in case of IEPC </a:t>
+              <a:t>CodeEU-94: </a:t>
             </a:r>
             <a:r>
               <a:rPr lang="en-US" sz="1200" spc="-1" dirty="0" err="1">
@@ -3680,7 +3083,7 @@
                   <a:srgbClr val="000000"/>
                 </a:solidFill>
               </a:rPr>
-              <a:t>WheelHub</a:t>
+              <a:t>DistanceRun</a:t>
             </a:r>
             <a:r>
               <a:rPr lang="en-US" sz="1200" spc="-1" dirty="0">
@@ -3688,7 +3091,7 @@
                   <a:srgbClr val="000000"/>
                 </a:solidFill>
               </a:rPr>
-              <a:t> motor and only one side is measured</a:t>
+              <a:t> got an unexpected response</a:t>
             </a:r>
           </a:p>
           <a:p>
@@ -3714,7 +3117,23 @@
                   <a:srgbClr val="000000"/>
                 </a:solidFill>
               </a:rPr>
-              <a:t>CodeEU-250: Maximum vehicle speed exceeded during pre-processing</a:t>
+              <a:t>CodeEU-153: </a:t>
+            </a:r>
+            <a:r>
+              <a:rPr lang="en-US" sz="1200" spc="-1" dirty="0" err="1">
+                <a:solidFill>
+                  <a:srgbClr val="000000"/>
+                </a:solidFill>
+              </a:rPr>
+              <a:t>DrivingActionAccelerate</a:t>
+            </a:r>
+            <a:r>
+              <a:rPr lang="en-US" sz="1200" spc="-1" dirty="0">
+                <a:solidFill>
+                  <a:srgbClr val="000000"/>
+                </a:solidFill>
+              </a:rPr>
+              <a:t>: Failed to find operating point after Overload</a:t>
             </a:r>
           </a:p>
           <a:p>
@@ -3740,7 +3159,7 @@
                   <a:srgbClr val="000000"/>
                 </a:solidFill>
               </a:rPr>
-              <a:t>CodeEU-253: Replace VTP </a:t>
+              <a:t>CodeEU-158: Urban </a:t>
             </a:r>
             <a:r>
               <a:rPr lang="en-US" sz="1200" spc="-1" dirty="0" err="1">
@@ -3748,7 +3167,7 @@
                   <a:srgbClr val="000000"/>
                 </a:solidFill>
               </a:rPr>
-              <a:t>HeavyBus</a:t>
+              <a:t>RefLoad</a:t>
             </a:r>
             <a:r>
               <a:rPr lang="en-US" sz="1200" spc="-1" dirty="0">
@@ -3756,7 +3175,39 @@
                   <a:srgbClr val="000000"/>
                 </a:solidFill>
               </a:rPr>
-              <a:t> in Generic Vehicles with VTP Truck</a:t>
+              <a:t> </a:t>
+            </a:r>
+            <a:r>
+              <a:rPr lang="en-US" sz="1200" spc="-1" dirty="0" err="1">
+                <a:solidFill>
+                  <a:srgbClr val="000000"/>
+                </a:solidFill>
+              </a:rPr>
+              <a:t>DrivingActionAccelerate</a:t>
+            </a:r>
+            <a:r>
+              <a:rPr lang="en-US" sz="1200" spc="-1" dirty="0">
+                <a:solidFill>
+                  <a:srgbClr val="000000"/>
+                </a:solidFill>
+              </a:rPr>
+              <a:t>: Failed to find operating point (IEPC </a:t>
+            </a:r>
+            <a:r>
+              <a:rPr lang="en-US" sz="1200" spc="-1" dirty="0" err="1">
+                <a:solidFill>
+                  <a:srgbClr val="000000"/>
+                </a:solidFill>
+              </a:rPr>
+              <a:t>Wheelhub</a:t>
+            </a:r>
+            <a:r>
+              <a:rPr lang="en-US" sz="1200" spc="-1" dirty="0">
+                <a:solidFill>
+                  <a:srgbClr val="000000"/>
+                </a:solidFill>
+              </a:rPr>
+              <a:t> 1 measured)</a:t>
             </a:r>
           </a:p>
           <a:p>
@@ -3782,23 +3233,7 @@
                   <a:srgbClr val="000000"/>
                 </a:solidFill>
               </a:rPr>
-              <a:t>CodeEU-259: Inconsistent calculation of </a:t>
-            </a:r>
-            <a:r>
-              <a:rPr lang="en-US" sz="1200" spc="-1" dirty="0" err="1">
-                <a:solidFill>
-                  <a:srgbClr val="000000"/>
-                </a:solidFill>
-              </a:rPr>
-              <a:t>AverageRRC</a:t>
-            </a:r>
-            <a:r>
-              <a:rPr lang="en-US" sz="1200" spc="-1" dirty="0">
-                <a:solidFill>
-                  <a:srgbClr val="000000"/>
-                </a:solidFill>
-              </a:rPr>
-              <a:t> in CIF</a:t>
+              <a:t>CodeEU-168: Vecto Declaration Simulation with P1-Hybrid shows multiple errors - Simulation Aborts!</a:t>
             </a:r>
           </a:p>
           <a:p>
@@ -3824,7 +3259,23 @@
                   <a:srgbClr val="000000"/>
                 </a:solidFill>
               </a:rPr>
-              <a:t>CodeEU-260: Handling of overload buffer in case Continuous Torque is 0Nm</a:t>
+              <a:t>CodeEU-191: Boosting limits HEV </a:t>
+            </a:r>
+            <a:r>
+              <a:rPr lang="en-US" sz="1200" spc="-1" dirty="0" err="1">
+                <a:solidFill>
+                  <a:srgbClr val="000000"/>
+                </a:solidFill>
+              </a:rPr>
+              <a:t>ovc</a:t>
+            </a:r>
+            <a:r>
+              <a:rPr lang="en-US" sz="1200" spc="-1" dirty="0">
+                <a:solidFill>
+                  <a:srgbClr val="000000"/>
+                </a:solidFill>
+              </a:rPr>
+              <a:t> are not working</a:t>
             </a:r>
           </a:p>
           <a:p>
@@ -3850,23 +3301,7 @@
                   <a:srgbClr val="000000"/>
                 </a:solidFill>
               </a:rPr>
-              <a:t>CodeEU-261: </a:t>
-            </a:r>
-            <a:r>
-              <a:rPr lang="en-US" sz="1200" spc="-1" dirty="0" err="1">
-                <a:solidFill>
-                  <a:srgbClr val="000000"/>
-                </a:solidFill>
-              </a:rPr>
-              <a:t>SuperCap</a:t>
-            </a:r>
-            <a:r>
-              <a:rPr lang="en-US" sz="1200" spc="-1" dirty="0">
-                <a:solidFill>
-                  <a:srgbClr val="000000"/>
-                </a:solidFill>
-              </a:rPr>
-              <a:t> internal resistance standard values correction</a:t>
+              <a:t>CodeEU-202: EMS Standard Values: Continuous/Overload Torque 0 Nm</a:t>
             </a:r>
           </a:p>
           <a:p>
@@ -3892,7 +3327,23 @@
                   <a:srgbClr val="000000"/>
                 </a:solidFill>
               </a:rPr>
-              <a:t>CodeEU-263: Determination of rated power for IEPCs for MRF and CIF</a:t>
+              <a:t>CodeEU-203: </a:t>
+            </a:r>
+            <a:r>
+              <a:rPr lang="en-US" sz="1200" spc="-1" dirty="0" err="1">
+                <a:solidFill>
+                  <a:srgbClr val="000000"/>
+                </a:solidFill>
+              </a:rPr>
+              <a:t>HybridStrategy</a:t>
+            </a:r>
+            <a:r>
+              <a:rPr lang="en-US" sz="1200" spc="-1" dirty="0">
+                <a:solidFill>
+                  <a:srgbClr val="000000"/>
+                </a:solidFill>
+              </a:rPr>
+              <a:t> error for IHPC type 1 hybrid lorry</a:t>
             </a:r>
           </a:p>
           <a:p>
@@ -3918,60 +3369,458 @@
                   <a:srgbClr val="000000"/>
                 </a:solidFill>
               </a:rPr>
-              <a:t>CodeEU-266: Fix Measured Speed Testcases</a:t>
-            </a:r>
-            <a:endParaRPr lang="en-US" sz="1200" b="0" strike="noStrike" spc="-1" dirty="0">
-              <a:latin typeface="Arial"/>
+              <a:t>CodeEU-206: VTP + PEMS test done by Renault Trucks France - VECTO tool errors most probably linked to automatic gearbox (with torque converter)</a:t>
+            </a:r>
+          </a:p>
+          <a:p>
+            <a:pPr marL="800280" lvl="1" indent="-343080">
+              <a:lnSpc>
+                <a:spcPct val="100000"/>
+              </a:lnSpc>
+              <a:spcBef>
+                <a:spcPts val="320"/>
+              </a:spcBef>
+              <a:buClr>
+                <a:srgbClr val="000000"/>
+              </a:buClr>
+              <a:buFont typeface="Symbol"/>
+              <a:buChar char=""/>
+              <a:tabLst>
+                <a:tab pos="1886040" algn="l"/>
+              </a:tabLst>
+            </a:pPr>
+            <a:r>
+              <a:rPr lang="en-US" sz="1200" spc="-1" dirty="0">
+                <a:solidFill>
+                  <a:srgbClr val="000000"/>
+                </a:solidFill>
+              </a:rPr>
+              <a:t>CodeEU-211: Hybrid P1 configurations with errors</a:t>
+            </a:r>
+          </a:p>
+          <a:p>
+            <a:pPr marL="800280" lvl="1" indent="-343080">
+              <a:lnSpc>
+                <a:spcPct val="100000"/>
+              </a:lnSpc>
+              <a:spcBef>
+                <a:spcPts val="320"/>
+              </a:spcBef>
+              <a:buClr>
+                <a:srgbClr val="000000"/>
+              </a:buClr>
+              <a:buFont typeface="Symbol"/>
+              <a:buChar char=""/>
+              <a:tabLst>
+                <a:tab pos="1886040" algn="l"/>
+              </a:tabLst>
+            </a:pPr>
+            <a:r>
+              <a:rPr lang="en-US" sz="1200" spc="-1" dirty="0">
+                <a:solidFill>
+                  <a:srgbClr val="000000"/>
+                </a:solidFill>
+              </a:rPr>
+              <a:t>CodeEU-215: </a:t>
+            </a:r>
+            <a:r>
+              <a:rPr lang="en-US" sz="1200" spc="-1" dirty="0" err="1">
+                <a:solidFill>
+                  <a:srgbClr val="000000"/>
+                </a:solidFill>
+              </a:rPr>
+              <a:t>MultiStep</a:t>
+            </a:r>
+            <a:r>
+              <a:rPr lang="en-US" sz="1200" spc="-1" dirty="0">
+                <a:solidFill>
+                  <a:srgbClr val="000000"/>
+                </a:solidFill>
+              </a:rPr>
+              <a:t> tool help</a:t>
+            </a:r>
+          </a:p>
+          <a:p>
+            <a:pPr marL="800280" lvl="1" indent="-343080">
+              <a:lnSpc>
+                <a:spcPct val="100000"/>
+              </a:lnSpc>
+              <a:spcBef>
+                <a:spcPts val="320"/>
+              </a:spcBef>
+              <a:buClr>
+                <a:srgbClr val="000000"/>
+              </a:buClr>
+              <a:buFont typeface="Symbol"/>
+              <a:buChar char=""/>
+              <a:tabLst>
+                <a:tab pos="1886040" algn="l"/>
+              </a:tabLst>
+            </a:pPr>
+            <a:r>
+              <a:rPr lang="en-US" sz="1200" spc="-1" dirty="0">
+                <a:solidFill>
+                  <a:srgbClr val="000000"/>
+                </a:solidFill>
+              </a:rPr>
+              <a:t>CodeEU-216: </a:t>
+            </a:r>
+            <a:r>
+              <a:rPr lang="en-US" sz="1200" spc="-1" dirty="0" err="1">
+                <a:solidFill>
+                  <a:srgbClr val="000000"/>
+                </a:solidFill>
+              </a:rPr>
+              <a:t>NrOfGears</a:t>
+            </a:r>
+            <a:r>
+              <a:rPr lang="en-US" sz="1200" spc="-1" dirty="0">
+                <a:solidFill>
+                  <a:srgbClr val="000000"/>
+                </a:solidFill>
+              </a:rPr>
+              <a:t> in CIF is 1 for IEPC no matter how many gears it has</a:t>
+            </a:r>
+          </a:p>
+          <a:p>
+            <a:pPr marL="800280" lvl="1" indent="-343080">
+              <a:lnSpc>
+                <a:spcPct val="100000"/>
+              </a:lnSpc>
+              <a:spcBef>
+                <a:spcPts val="320"/>
+              </a:spcBef>
+              <a:buClr>
+                <a:srgbClr val="000000"/>
+              </a:buClr>
+              <a:buFont typeface="Symbol"/>
+              <a:buChar char=""/>
+              <a:tabLst>
+                <a:tab pos="1886040" algn="l"/>
+              </a:tabLst>
+            </a:pPr>
+            <a:r>
+              <a:rPr lang="en-US" sz="1200" spc="-1" dirty="0">
+                <a:solidFill>
+                  <a:srgbClr val="000000"/>
+                </a:solidFill>
+              </a:rPr>
+              <a:t>CodeEU-220: Error manual transmission 2. gear</a:t>
+            </a:r>
+          </a:p>
+          <a:p>
+            <a:pPr marL="800280" lvl="1" indent="-343080">
+              <a:lnSpc>
+                <a:spcPct val="100000"/>
+              </a:lnSpc>
+              <a:spcBef>
+                <a:spcPts val="320"/>
+              </a:spcBef>
+              <a:buClr>
+                <a:srgbClr val="000000"/>
+              </a:buClr>
+              <a:buFont typeface="Symbol"/>
+              <a:buChar char=""/>
+              <a:tabLst>
+                <a:tab pos="1886040" algn="l"/>
+              </a:tabLst>
+            </a:pPr>
+            <a:r>
+              <a:rPr lang="en-US" sz="1200" spc="-1" dirty="0">
+                <a:solidFill>
+                  <a:srgbClr val="000000"/>
+                </a:solidFill>
+              </a:rPr>
+              <a:t>CodeEU-224: Issue with PEV complete vehicle simulation (Vecto </a:t>
+            </a:r>
+            <a:r>
+              <a:rPr lang="en-US" sz="1200" spc="-1" dirty="0" err="1">
+                <a:solidFill>
+                  <a:srgbClr val="000000"/>
+                </a:solidFill>
+              </a:rPr>
+              <a:t>MultiStage</a:t>
+            </a:r>
+            <a:r>
+              <a:rPr lang="en-US" sz="1200" spc="-1" dirty="0">
+                <a:solidFill>
+                  <a:srgbClr val="000000"/>
+                </a:solidFill>
+              </a:rPr>
+              <a:t>)</a:t>
+            </a:r>
+          </a:p>
+          <a:p>
+            <a:pPr marL="800280" lvl="1" indent="-343080">
+              <a:lnSpc>
+                <a:spcPct val="100000"/>
+              </a:lnSpc>
+              <a:spcBef>
+                <a:spcPts val="320"/>
+              </a:spcBef>
+              <a:buClr>
+                <a:srgbClr val="000000"/>
+              </a:buClr>
+              <a:buFont typeface="Symbol"/>
+              <a:buChar char=""/>
+              <a:tabLst>
+                <a:tab pos="1886040" algn="l"/>
+              </a:tabLst>
+            </a:pPr>
+            <a:r>
+              <a:rPr lang="en-US" sz="1200" spc="-1" dirty="0">
+                <a:solidFill>
+                  <a:srgbClr val="000000"/>
+                </a:solidFill>
+              </a:rPr>
+              <a:t>CodeEU-231: IVECO CONFIDENTIAL : hybrid buses completed simulation aborted</a:t>
+            </a:r>
+          </a:p>
+          <a:p>
+            <a:pPr marL="800280" lvl="1" indent="-343080">
+              <a:lnSpc>
+                <a:spcPct val="100000"/>
+              </a:lnSpc>
+              <a:spcBef>
+                <a:spcPts val="320"/>
+              </a:spcBef>
+              <a:buClr>
+                <a:srgbClr val="000000"/>
+              </a:buClr>
+              <a:buFont typeface="Symbol"/>
+              <a:buChar char=""/>
+              <a:tabLst>
+                <a:tab pos="1886040" algn="l"/>
+              </a:tabLst>
+            </a:pPr>
+            <a:r>
+              <a:rPr lang="en-US" sz="1200" spc="-1" dirty="0">
+                <a:solidFill>
+                  <a:srgbClr val="000000"/>
+                </a:solidFill>
+              </a:rPr>
+              <a:t>CodeEU-234: Error Conventional Lorry Gear: 1C </a:t>
+            </a:r>
+            <a:r>
+              <a:rPr lang="en-US" sz="1200" spc="-1" dirty="0" err="1">
+                <a:solidFill>
+                  <a:srgbClr val="000000"/>
+                </a:solidFill>
+              </a:rPr>
+              <a:t>DistanceRun</a:t>
+            </a:r>
+            <a:r>
+              <a:rPr lang="en-US" sz="1200" spc="-1" dirty="0">
+                <a:solidFill>
+                  <a:srgbClr val="000000"/>
+                </a:solidFill>
+              </a:rPr>
+              <a:t> got an unexpected response</a:t>
+            </a:r>
+          </a:p>
+          <a:p>
+            <a:pPr marL="800280" lvl="1" indent="-343080">
+              <a:lnSpc>
+                <a:spcPct val="100000"/>
+              </a:lnSpc>
+              <a:spcBef>
+                <a:spcPts val="320"/>
+              </a:spcBef>
+              <a:buClr>
+                <a:srgbClr val="000000"/>
+              </a:buClr>
+              <a:buFont typeface="Symbol"/>
+              <a:buChar char=""/>
+              <a:tabLst>
+                <a:tab pos="1886040" algn="l"/>
+              </a:tabLst>
+            </a:pPr>
+            <a:r>
+              <a:rPr lang="en-US" sz="1200" spc="-1" dirty="0">
+                <a:solidFill>
+                  <a:srgbClr val="000000"/>
+                </a:solidFill>
+              </a:rPr>
+              <a:t>CodeEU-235: </a:t>
+            </a:r>
+            <a:r>
+              <a:rPr lang="en-US" sz="1200" spc="-1" dirty="0" err="1">
+                <a:solidFill>
+                  <a:srgbClr val="000000"/>
+                </a:solidFill>
+              </a:rPr>
+              <a:t>Tyre</a:t>
+            </a:r>
+            <a:r>
+              <a:rPr lang="en-US" sz="1200" spc="-1" dirty="0">
+                <a:solidFill>
+                  <a:srgbClr val="000000"/>
+                </a:solidFill>
+              </a:rPr>
+              <a:t> error calculation buses "invalid </a:t>
+            </a:r>
+            <a:r>
+              <a:rPr lang="en-US" sz="1200" spc="-1" dirty="0" err="1">
+                <a:solidFill>
+                  <a:srgbClr val="000000"/>
+                </a:solidFill>
+              </a:rPr>
+              <a:t>xsi:type</a:t>
+            </a:r>
+            <a:r>
+              <a:rPr lang="en-US" sz="1200" spc="-1" dirty="0">
+                <a:solidFill>
+                  <a:srgbClr val="000000"/>
+                </a:solidFill>
+              </a:rPr>
+              <a:t> '</a:t>
+            </a:r>
+            <a:r>
+              <a:rPr lang="en-US" sz="1200" spc="-1" dirty="0" err="1">
+                <a:solidFill>
+                  <a:srgbClr val="000000"/>
+                </a:solidFill>
+              </a:rPr>
+              <a:t>TyreDataDeclarationType</a:t>
+            </a:r>
+            <a:r>
+              <a:rPr lang="en-US" sz="1200" spc="-1" dirty="0">
+                <a:solidFill>
+                  <a:srgbClr val="000000"/>
+                </a:solidFill>
+              </a:rPr>
+              <a:t>'"</a:t>
+            </a:r>
+          </a:p>
+          <a:p>
+            <a:pPr marL="800280" lvl="1" indent="-343080">
+              <a:lnSpc>
+                <a:spcPct val="100000"/>
+              </a:lnSpc>
+              <a:spcBef>
+                <a:spcPts val="320"/>
+              </a:spcBef>
+              <a:buClr>
+                <a:srgbClr val="000000"/>
+              </a:buClr>
+              <a:buFont typeface="Symbol"/>
+              <a:buChar char=""/>
+              <a:tabLst>
+                <a:tab pos="1886040" algn="l"/>
+              </a:tabLst>
+            </a:pPr>
+            <a:r>
+              <a:rPr lang="en-US" sz="1200" spc="-1" dirty="0">
+                <a:solidFill>
+                  <a:srgbClr val="000000"/>
+                </a:solidFill>
+              </a:rPr>
+              <a:t>CodeEU-238: Bus VIF files not valid in Multistep VECTO</a:t>
+            </a:r>
+          </a:p>
+          <a:p>
+            <a:pPr marL="800280" lvl="1" indent="-343080">
+              <a:lnSpc>
+                <a:spcPct val="100000"/>
+              </a:lnSpc>
+              <a:spcBef>
+                <a:spcPts val="320"/>
+              </a:spcBef>
+              <a:buClr>
+                <a:srgbClr val="000000"/>
+              </a:buClr>
+              <a:buFont typeface="Symbol"/>
+              <a:buChar char=""/>
+              <a:tabLst>
+                <a:tab pos="1886040" algn="l"/>
+              </a:tabLst>
+            </a:pPr>
+            <a:r>
+              <a:rPr lang="en-US" sz="1200" spc="-1" dirty="0">
+                <a:solidFill>
+                  <a:srgbClr val="000000"/>
+                </a:solidFill>
+              </a:rPr>
+              <a:t>CodeEU-243: Simulation aborted: Gear 5 </a:t>
+            </a:r>
+            <a:r>
+              <a:rPr lang="en-US" sz="1200" spc="-1" dirty="0" err="1">
+                <a:solidFill>
+                  <a:srgbClr val="000000"/>
+                </a:solidFill>
+              </a:rPr>
+              <a:t>Lossmap</a:t>
+            </a:r>
+            <a:r>
+              <a:rPr lang="en-US" sz="1200" spc="-1" dirty="0">
+                <a:solidFill>
+                  <a:srgbClr val="000000"/>
+                </a:solidFill>
+              </a:rPr>
+              <a:t> not </a:t>
+            </a:r>
+            <a:r>
+              <a:rPr lang="en-US" sz="1200" spc="-1" dirty="0" err="1">
+                <a:solidFill>
+                  <a:srgbClr val="000000"/>
+                </a:solidFill>
+              </a:rPr>
+              <a:t>sufficiant</a:t>
+            </a:r>
+            <a:endParaRPr lang="en-US" sz="1200" spc="-1" dirty="0">
+              <a:solidFill>
+                <a:srgbClr val="000000"/>
+              </a:solidFill>
             </a:endParaRPr>
           </a:p>
           <a:p>
+            <a:pPr marL="800280" lvl="1" indent="-343080">
+              <a:lnSpc>
+                <a:spcPct val="100000"/>
+              </a:lnSpc>
+              <a:spcBef>
+                <a:spcPts val="320"/>
+              </a:spcBef>
+              <a:buClr>
+                <a:srgbClr val="000000"/>
+              </a:buClr>
+              <a:buFont typeface="Symbol"/>
+              <a:buChar char=""/>
+              <a:tabLst>
+                <a:tab pos="1886040" algn="l"/>
+              </a:tabLst>
+            </a:pPr>
+            <a:r>
+              <a:rPr lang="en-US" sz="1200" spc="-1" dirty="0">
+                <a:solidFill>
+                  <a:srgbClr val="000000"/>
+                </a:solidFill>
+              </a:rPr>
+              <a:t>CodeEU-244: Signature validation fails for old (prior to v4) Manufacturer reports</a:t>
+            </a:r>
+          </a:p>
+          <a:p>
             <a:pPr>
               <a:lnSpc>
                 <a:spcPct val="100000"/>
               </a:lnSpc>
-              <a:spcBef>
-                <a:spcPts val="281"/>
-              </a:spcBef>
               <a:buNone/>
               <a:tabLst>
                 <a:tab pos="1886040" algn="l"/>
               </a:tabLst>
             </a:pPr>
-            <a:endParaRPr lang="en-US" sz="1200" b="0" strike="noStrike" spc="-1" dirty="0">
-              <a:latin typeface="Arial"/>
-            </a:endParaRPr>
-          </a:p>
-          <a:p>
-            <a:pPr>
-              <a:lnSpc>
-                <a:spcPct val="100000"/>
-              </a:lnSpc>
-              <a:buNone/>
-              <a:tabLst>
-                <a:tab pos="1886040" algn="l"/>
-              </a:tabLst>
-            </a:pPr>
             <a:endParaRPr lang="en-US" sz="1400" b="0" strike="noStrike" spc="-1" dirty="0">
               <a:latin typeface="Arial"/>
             </a:endParaRPr>
           </a:p>
-          <a:p>
-            <a:pPr>
-              <a:lnSpc>
-                <a:spcPct val="100000"/>
-              </a:lnSpc>
-              <a:buNone/>
-              <a:tabLst>
-                <a:tab pos="1886040" algn="l"/>
-              </a:tabLst>
-            </a:pPr>
-            <a:endParaRPr lang="en-US" sz="1400" b="0" strike="noStrike" spc="-1" dirty="0">
-              <a:latin typeface="Arial"/>
-            </a:endParaRPr>
-          </a:p>
         </p:txBody>
       </p:sp>
     </p:spTree>
+    <p:extLst>
+      <p:ext uri="{BB962C8B-B14F-4D97-AF65-F5344CB8AC3E}">
+        <p14:creationId xmlns:p14="http://schemas.microsoft.com/office/powerpoint/2010/main" val="4241918010"/>
+      </p:ext>
+    </p:extLst>
   </p:cSld>
   <p:clrMapOvr>
     <a:masterClrMapping/>
@@ -4038,7 +3887,7 @@
                 </a:solidFill>
                 <a:latin typeface="Arial"/>
               </a:rPr>
-              <a:t>Vecto 4.0.1.3217 OFFICIAL RELEASE</a:t>
+              <a:t>Vecto 4.0.2.3273 OFFICIAL RELEASE</a:t>
             </a:r>
             <a:br>
               <a:rPr sz="2400" dirty="0"/>
@@ -4047,7 +3896,7 @@
               <a:rPr lang="en-US" sz="1600" spc="-1" dirty="0">
                 <a:latin typeface="Arial"/>
               </a:rPr>
-              <a:t>23.10.2023</a:t>
+              <a:t>18.12.2023</a:t>
             </a:r>
             <a:endParaRPr lang="en-US" sz="1600" b="0" strike="noStrike" spc="-1" dirty="0">
               <a:latin typeface="Arial"/>
@@ -4106,6 +3955,466 @@
                   <a:srgbClr val="000000"/>
                 </a:solidFill>
               </a:rPr>
+              <a:t>Bugfixes (2/2)</a:t>
+            </a:r>
+          </a:p>
+          <a:p>
+            <a:pPr marL="800280" lvl="1" indent="-343080">
+              <a:lnSpc>
+                <a:spcPct val="100000"/>
+              </a:lnSpc>
+              <a:spcBef>
+                <a:spcPts val="320"/>
+              </a:spcBef>
+              <a:buClr>
+                <a:srgbClr val="000000"/>
+              </a:buClr>
+              <a:buFont typeface="Symbol"/>
+              <a:buChar char=""/>
+              <a:tabLst>
+                <a:tab pos="1886040" algn="l"/>
+              </a:tabLst>
+            </a:pPr>
+            <a:r>
+              <a:rPr lang="en-US" sz="1200" spc="-1" dirty="0">
+                <a:solidFill>
+                  <a:srgbClr val="000000"/>
+                </a:solidFill>
+              </a:rPr>
+              <a:t>CodeEU-249: Fix handling gear torque limits in case of IEPC </a:t>
+            </a:r>
+            <a:r>
+              <a:rPr lang="en-US" sz="1200" spc="-1" dirty="0" err="1">
+                <a:solidFill>
+                  <a:srgbClr val="000000"/>
+                </a:solidFill>
+              </a:rPr>
+              <a:t>WheelHub</a:t>
+            </a:r>
+            <a:r>
+              <a:rPr lang="en-US" sz="1200" spc="-1" dirty="0">
+                <a:solidFill>
+                  <a:srgbClr val="000000"/>
+                </a:solidFill>
+              </a:rPr>
+              <a:t> motor and only one side is measured</a:t>
+            </a:r>
+          </a:p>
+          <a:p>
+            <a:pPr marL="800280" lvl="1" indent="-343080">
+              <a:lnSpc>
+                <a:spcPct val="100000"/>
+              </a:lnSpc>
+              <a:spcBef>
+                <a:spcPts val="320"/>
+              </a:spcBef>
+              <a:buClr>
+                <a:srgbClr val="000000"/>
+              </a:buClr>
+              <a:buFont typeface="Symbol"/>
+              <a:buChar char=""/>
+              <a:tabLst>
+                <a:tab pos="1886040" algn="l"/>
+              </a:tabLst>
+            </a:pPr>
+            <a:r>
+              <a:rPr lang="en-US" sz="1200" spc="-1" dirty="0">
+                <a:solidFill>
+                  <a:srgbClr val="000000"/>
+                </a:solidFill>
+              </a:rPr>
+              <a:t>CodeEU-250: Maximum vehicle speed exceeded during pre-processing</a:t>
+            </a:r>
+          </a:p>
+          <a:p>
+            <a:pPr marL="800280" lvl="1" indent="-343080">
+              <a:lnSpc>
+                <a:spcPct val="100000"/>
+              </a:lnSpc>
+              <a:spcBef>
+                <a:spcPts val="320"/>
+              </a:spcBef>
+              <a:buClr>
+                <a:srgbClr val="000000"/>
+              </a:buClr>
+              <a:buFont typeface="Symbol"/>
+              <a:buChar char=""/>
+              <a:tabLst>
+                <a:tab pos="1886040" algn="l"/>
+              </a:tabLst>
+            </a:pPr>
+            <a:r>
+              <a:rPr lang="en-US" sz="1200" spc="-1" dirty="0">
+                <a:solidFill>
+                  <a:srgbClr val="000000"/>
+                </a:solidFill>
+              </a:rPr>
+              <a:t>CodeEU-253: Replace VTP </a:t>
+            </a:r>
+            <a:r>
+              <a:rPr lang="en-US" sz="1200" spc="-1" dirty="0" err="1">
+                <a:solidFill>
+                  <a:srgbClr val="000000"/>
+                </a:solidFill>
+              </a:rPr>
+              <a:t>HeavyBus</a:t>
+            </a:r>
+            <a:r>
+              <a:rPr lang="en-US" sz="1200" spc="-1" dirty="0">
+                <a:solidFill>
+                  <a:srgbClr val="000000"/>
+                </a:solidFill>
+              </a:rPr>
+              <a:t> in Generic Vehicles with VTP Truck</a:t>
+            </a:r>
+          </a:p>
+          <a:p>
+            <a:pPr marL="800280" lvl="1" indent="-343080">
+              <a:lnSpc>
+                <a:spcPct val="100000"/>
+              </a:lnSpc>
+              <a:spcBef>
+                <a:spcPts val="320"/>
+              </a:spcBef>
+              <a:buClr>
+                <a:srgbClr val="000000"/>
+              </a:buClr>
+              <a:buFont typeface="Symbol"/>
+              <a:buChar char=""/>
+              <a:tabLst>
+                <a:tab pos="1886040" algn="l"/>
+              </a:tabLst>
+            </a:pPr>
+            <a:r>
+              <a:rPr lang="en-US" sz="1200" spc="-1" dirty="0">
+                <a:solidFill>
+                  <a:srgbClr val="000000"/>
+                </a:solidFill>
+              </a:rPr>
+              <a:t>CodeEU-259: Inconsistent calculation of </a:t>
+            </a:r>
+            <a:r>
+              <a:rPr lang="en-US" sz="1200" spc="-1" dirty="0" err="1">
+                <a:solidFill>
+                  <a:srgbClr val="000000"/>
+                </a:solidFill>
+              </a:rPr>
+              <a:t>AverageRRC</a:t>
+            </a:r>
+            <a:r>
+              <a:rPr lang="en-US" sz="1200" spc="-1" dirty="0">
+                <a:solidFill>
+                  <a:srgbClr val="000000"/>
+                </a:solidFill>
+              </a:rPr>
+              <a:t> in CIF</a:t>
+            </a:r>
+          </a:p>
+          <a:p>
+            <a:pPr marL="800280" lvl="1" indent="-343080">
+              <a:lnSpc>
+                <a:spcPct val="100000"/>
+              </a:lnSpc>
+              <a:spcBef>
+                <a:spcPts val="320"/>
+              </a:spcBef>
+              <a:buClr>
+                <a:srgbClr val="000000"/>
+              </a:buClr>
+              <a:buFont typeface="Symbol"/>
+              <a:buChar char=""/>
+              <a:tabLst>
+                <a:tab pos="1886040" algn="l"/>
+              </a:tabLst>
+            </a:pPr>
+            <a:r>
+              <a:rPr lang="en-US" sz="1200" spc="-1" dirty="0">
+                <a:solidFill>
+                  <a:srgbClr val="000000"/>
+                </a:solidFill>
+              </a:rPr>
+              <a:t>CodeEU-260: Handling of overload buffer in case Continuous Torque is 0Nm</a:t>
+            </a:r>
+          </a:p>
+          <a:p>
+            <a:pPr marL="800280" lvl="1" indent="-343080">
+              <a:lnSpc>
+                <a:spcPct val="100000"/>
+              </a:lnSpc>
+              <a:spcBef>
+                <a:spcPts val="320"/>
+              </a:spcBef>
+              <a:buClr>
+                <a:srgbClr val="000000"/>
+              </a:buClr>
+              <a:buFont typeface="Symbol"/>
+              <a:buChar char=""/>
+              <a:tabLst>
+                <a:tab pos="1886040" algn="l"/>
+              </a:tabLst>
+            </a:pPr>
+            <a:r>
+              <a:rPr lang="en-US" sz="1200" spc="-1" dirty="0">
+                <a:solidFill>
+                  <a:srgbClr val="000000"/>
+                </a:solidFill>
+              </a:rPr>
+              <a:t>CodeEU-261: </a:t>
+            </a:r>
+            <a:r>
+              <a:rPr lang="en-US" sz="1200" spc="-1" dirty="0" err="1">
+                <a:solidFill>
+                  <a:srgbClr val="000000"/>
+                </a:solidFill>
+              </a:rPr>
+              <a:t>SuperCap</a:t>
+            </a:r>
+            <a:r>
+              <a:rPr lang="en-US" sz="1200" spc="-1" dirty="0">
+                <a:solidFill>
+                  <a:srgbClr val="000000"/>
+                </a:solidFill>
+              </a:rPr>
+              <a:t> internal resistance standard values correction</a:t>
+            </a:r>
+          </a:p>
+          <a:p>
+            <a:pPr marL="800280" lvl="1" indent="-343080">
+              <a:lnSpc>
+                <a:spcPct val="100000"/>
+              </a:lnSpc>
+              <a:spcBef>
+                <a:spcPts val="320"/>
+              </a:spcBef>
+              <a:buClr>
+                <a:srgbClr val="000000"/>
+              </a:buClr>
+              <a:buFont typeface="Symbol"/>
+              <a:buChar char=""/>
+              <a:tabLst>
+                <a:tab pos="1886040" algn="l"/>
+              </a:tabLst>
+            </a:pPr>
+            <a:r>
+              <a:rPr lang="en-US" sz="1200" spc="-1" dirty="0">
+                <a:solidFill>
+                  <a:srgbClr val="000000"/>
+                </a:solidFill>
+              </a:rPr>
+              <a:t>CodeEU-263: Determination of rated power for IEPCs for MRF and CIF</a:t>
+            </a:r>
+          </a:p>
+          <a:p>
+            <a:pPr marL="800280" lvl="1" indent="-343080">
+              <a:lnSpc>
+                <a:spcPct val="100000"/>
+              </a:lnSpc>
+              <a:spcBef>
+                <a:spcPts val="320"/>
+              </a:spcBef>
+              <a:buClr>
+                <a:srgbClr val="000000"/>
+              </a:buClr>
+              <a:buFont typeface="Symbol"/>
+              <a:buChar char=""/>
+              <a:tabLst>
+                <a:tab pos="1886040" algn="l"/>
+              </a:tabLst>
+            </a:pPr>
+            <a:r>
+              <a:rPr lang="en-US" sz="1200" spc="-1" dirty="0">
+                <a:solidFill>
+                  <a:srgbClr val="000000"/>
+                </a:solidFill>
+              </a:rPr>
+              <a:t>CodeEU-266: Fix Measured Speed Testcases</a:t>
+            </a:r>
+            <a:endParaRPr lang="en-US" sz="1200" b="0" strike="noStrike" spc="-1" dirty="0">
+              <a:latin typeface="Arial"/>
+            </a:endParaRPr>
+          </a:p>
+          <a:p>
+            <a:pPr>
+              <a:lnSpc>
+                <a:spcPct val="100000"/>
+              </a:lnSpc>
+              <a:spcBef>
+                <a:spcPts val="281"/>
+              </a:spcBef>
+              <a:buNone/>
+              <a:tabLst>
+                <a:tab pos="1886040" algn="l"/>
+              </a:tabLst>
+            </a:pPr>
+            <a:endParaRPr lang="en-US" sz="1200" b="0" strike="noStrike" spc="-1" dirty="0">
+              <a:latin typeface="Arial"/>
+            </a:endParaRPr>
+          </a:p>
+          <a:p>
+            <a:pPr>
+              <a:lnSpc>
+                <a:spcPct val="100000"/>
+              </a:lnSpc>
+              <a:buNone/>
+              <a:tabLst>
+                <a:tab pos="1886040" algn="l"/>
+              </a:tabLst>
+            </a:pPr>
+            <a:endParaRPr lang="en-US" sz="1400" b="0" strike="noStrike" spc="-1" dirty="0">
+              <a:latin typeface="Arial"/>
+            </a:endParaRPr>
+          </a:p>
+          <a:p>
+            <a:pPr>
+              <a:lnSpc>
+                <a:spcPct val="100000"/>
+              </a:lnSpc>
+              <a:buNone/>
+              <a:tabLst>
+                <a:tab pos="1886040" algn="l"/>
+              </a:tabLst>
+            </a:pPr>
+            <a:endParaRPr lang="en-US" sz="1400" b="0" strike="noStrike" spc="-1" dirty="0">
+              <a:latin typeface="Arial"/>
+            </a:endParaRPr>
+          </a:p>
+        </p:txBody>
+      </p:sp>
+    </p:spTree>
+  </p:cSld>
+  <p:clrMapOvr>
+    <a:masterClrMapping/>
+  </p:clrMapOvr>
+</p:sld>
+</file>
+
+<file path=ppt/slides/slide5.xml><?xml version="1.0" encoding="utf-8"?>
+<p:sld xmlns:a="http://schemas.openxmlformats.org/drawingml/2006/main" xmlns:r="http://schemas.openxmlformats.org/officeDocument/2006/relationships" xmlns:p="http://schemas.openxmlformats.org/presentationml/2006/main">
+  <p:cSld>
+    <p:spTree>
+      <p:nvGrpSpPr>
+        <p:cNvPr id="1" name=""/>
+        <p:cNvGrpSpPr/>
+        <p:nvPr/>
+      </p:nvGrpSpPr>
+      <p:grpSpPr>
+        <a:xfrm>
+          <a:off x="0" y="0"/>
+          <a:ext cx="0" cy="0"/>
+          <a:chOff x="0" y="0"/>
+          <a:chExt cx="0" cy="0"/>
+        </a:xfrm>
+      </p:grpSpPr>
+      <p:sp>
+        <p:nvSpPr>
+          <p:cNvPr id="92" name="PlaceHolder 1"/>
+          <p:cNvSpPr>
+            <a:spLocks noGrp="1"/>
+          </p:cNvSpPr>
+          <p:nvPr>
+            <p:ph type="title"/>
+          </p:nvPr>
+        </p:nvSpPr>
+        <p:spPr>
+          <a:xfrm>
+            <a:off x="468360" y="476640"/>
+            <a:ext cx="8217720" cy="680400"/>
+          </a:xfrm>
+          <a:prstGeom prst="rect">
+            <a:avLst/>
+          </a:prstGeom>
+          <a:noFill/>
+          <a:ln w="0">
+            <a:noFill/>
+          </a:ln>
+        </p:spPr>
+        <p:txBody>
+          <a:bodyPr lIns="90000" tIns="45000" rIns="90000" bIns="45000" numCol="1" spcCol="0" anchor="ctr">
+            <a:noAutofit/>
+          </a:bodyPr>
+          <a:lstStyle/>
+          <a:p>
+            <a:pPr algn="ctr">
+              <a:lnSpc>
+                <a:spcPct val="100000"/>
+              </a:lnSpc>
+              <a:buNone/>
+            </a:pPr>
+            <a:r>
+              <a:rPr lang="en-US" sz="2400" b="1" strike="noStrike" spc="-1" dirty="0">
+                <a:solidFill>
+                  <a:srgbClr val="990000"/>
+                </a:solidFill>
+                <a:latin typeface="Arial"/>
+              </a:rPr>
+              <a:t>Vecto 4.0.1.3217 OFFICIAL RELEASE</a:t>
+            </a:r>
+            <a:br>
+              <a:rPr sz="2400" dirty="0"/>
+            </a:br>
+            <a:r>
+              <a:rPr lang="en-US" sz="1600" spc="-1" dirty="0">
+                <a:latin typeface="Arial"/>
+              </a:rPr>
+              <a:t>23.10.2023</a:t>
+            </a:r>
+            <a:endParaRPr lang="en-US" sz="1600" b="0" strike="noStrike" spc="-1" dirty="0">
+              <a:latin typeface="Arial"/>
+            </a:endParaRPr>
+          </a:p>
+        </p:txBody>
+      </p:sp>
+      <p:sp>
+        <p:nvSpPr>
+          <p:cNvPr id="93" name="PlaceHolder 2"/>
+          <p:cNvSpPr>
+            <a:spLocks noGrp="1"/>
+          </p:cNvSpPr>
+          <p:nvPr>
+            <p:ph/>
+          </p:nvPr>
+        </p:nvSpPr>
+        <p:spPr>
+          <a:xfrm>
+            <a:off x="323640" y="1268640"/>
+            <a:ext cx="8496360" cy="4823640"/>
+          </a:xfrm>
+          <a:prstGeom prst="rect">
+            <a:avLst/>
+          </a:prstGeom>
+          <a:noFill/>
+          <a:ln w="0">
+            <a:noFill/>
+          </a:ln>
+        </p:spPr>
+        <p:txBody>
+          <a:bodyPr lIns="90000" tIns="45000" rIns="90000" bIns="45000" numCol="1" spcCol="0" anchor="t">
+            <a:noAutofit/>
+          </a:bodyPr>
+          <a:lstStyle/>
+          <a:p>
+            <a:pPr marL="343080" indent="-343080">
+              <a:lnSpc>
+                <a:spcPct val="100000"/>
+              </a:lnSpc>
+              <a:spcBef>
+                <a:spcPts val="320"/>
+              </a:spcBef>
+              <a:buClr>
+                <a:srgbClr val="000000"/>
+              </a:buClr>
+              <a:buFont typeface="Symbol"/>
+              <a:buChar char=""/>
+              <a:tabLst>
+                <a:tab pos="1886040" algn="l"/>
+              </a:tabLst>
+            </a:pPr>
+            <a:r>
+              <a:rPr lang="en-US" sz="1600" b="1" spc="-1" dirty="0">
+                <a:solidFill>
+                  <a:srgbClr val="000000"/>
+                </a:solidFill>
+              </a:rPr>
               <a:t>Improvements</a:t>
             </a:r>
           </a:p>
@@ -4384,7 +4693,7 @@
 </p:sld>
 </file>
 
-<file path=ppt/slides/slide5.xml><?xml version="1.0" encoding="utf-8"?>
+<file path=ppt/slides/slide6.xml><?xml version="1.0" encoding="utf-8"?>
 <p:sld xmlns:a="http://schemas.openxmlformats.org/drawingml/2006/main" xmlns:r="http://schemas.openxmlformats.org/officeDocument/2006/relationships" xmlns:p="http://schemas.openxmlformats.org/presentationml/2006/main">
   <p:cSld>
     <p:spTree>
@@ -4627,7 +4936,7 @@
 </p:sld>
 </file>
 
-<file path=ppt/slides/slide6.xml><?xml version="1.0" encoding="utf-8"?>
+<file path=ppt/slides/slide7.xml><?xml version="1.0" encoding="utf-8"?>
 <p:sld xmlns:a="http://schemas.openxmlformats.org/drawingml/2006/main" xmlns:r="http://schemas.openxmlformats.org/officeDocument/2006/relationships" xmlns:p="http://schemas.openxmlformats.org/presentationml/2006/main">
   <p:cSld>
     <p:spTree>
@@ -4746,7 +5055,7 @@
 </p:sld>
 </file>
 
-<file path=ppt/slides/slide7.xml><?xml version="1.0" encoding="utf-8"?>
+<file path=ppt/slides/slide8.xml><?xml version="1.0" encoding="utf-8"?>
 <p:sld xmlns:a="http://schemas.openxmlformats.org/drawingml/2006/main" xmlns:r="http://schemas.openxmlformats.org/officeDocument/2006/relationships" xmlns:p="http://schemas.openxmlformats.org/presentationml/2006/main">
   <p:cSld>
     <p:spTree>
@@ -5088,7 +5397,7 @@
 </p:sld>
 </file>
 
-<file path=ppt/slides/slide8.xml><?xml version="1.0" encoding="utf-8"?>
+<file path=ppt/slides/slide9.xml><?xml version="1.0" encoding="utf-8"?>
 <p:sld xmlns:a="http://schemas.openxmlformats.org/drawingml/2006/main" xmlns:r="http://schemas.openxmlformats.org/officeDocument/2006/relationships" xmlns:p="http://schemas.openxmlformats.org/presentationml/2006/main">
   <p:cSld>
     <p:spTree>
@@ -6906,116 +7215,6 @@
     <p:extLst>
       <p:ext uri="{BB962C8B-B14F-4D97-AF65-F5344CB8AC3E}">
         <p14:creationId xmlns:p14="http://schemas.microsoft.com/office/powerpoint/2010/main" val="3933703563"/>
-      </p:ext>
-    </p:extLst>
-  </p:cSld>
-  <p:clrMapOvr>
-    <a:masterClrMapping/>
-  </p:clrMapOvr>
-</p:sld>
-</file>
-
-<file path=ppt/slides/slide9.xml><?xml version="1.0" encoding="utf-8"?>
-<p:sld xmlns:a="http://schemas.openxmlformats.org/drawingml/2006/main" xmlns:r="http://schemas.openxmlformats.org/officeDocument/2006/relationships" xmlns:p="http://schemas.openxmlformats.org/presentationml/2006/main">
-  <p:cSld>
-    <p:spTree>
-      <p:nvGrpSpPr>
-        <p:cNvPr id="1" name=""/>
-        <p:cNvGrpSpPr/>
-        <p:nvPr/>
-      </p:nvGrpSpPr>
-      <p:grpSpPr>
-        <a:xfrm>
-          <a:off x="0" y="0"/>
-          <a:ext cx="0" cy="0"/>
-          <a:chOff x="0" y="0"/>
-          <a:chExt cx="0" cy="0"/>
-        </a:xfrm>
-      </p:grpSpPr>
-      <p:sp>
-        <p:nvSpPr>
-          <p:cNvPr id="6" name="Inhaltsplatzhalter 5"/>
-          <p:cNvSpPr>
-            <a:spLocks noGrp="1"/>
-          </p:cNvSpPr>
-          <p:nvPr>
-            <p:ph idx="1"/>
-          </p:nvPr>
-        </p:nvSpPr>
-        <p:spPr>
-          <a:xfrm>
-            <a:off x="588206" y="1300092"/>
-            <a:ext cx="8394645" cy="4195735"/>
-          </a:xfrm>
-        </p:spPr>
-        <p:txBody>
-          <a:bodyPr>
-            <a:normAutofit/>
-          </a:bodyPr>
-          <a:lstStyle/>
-          <a:p>
-            <a:pPr>
-              <a:spcBef>
-                <a:spcPts val="1200"/>
-              </a:spcBef>
-            </a:pPr>
-            <a:r>
-              <a:rPr lang="en-US" sz="1800" dirty="0"/>
-              <a:t>XML Job Files &lt; v2.4 are no longer supported</a:t>
-            </a:r>
-          </a:p>
-          <a:p>
-            <a:pPr>
-              <a:spcBef>
-                <a:spcPts val="1200"/>
-              </a:spcBef>
-            </a:pPr>
-            <a:r>
-              <a:rPr lang="en-US" sz="1800" dirty="0"/>
-              <a:t>Dropped support for .NET Framework 4.5 (EOL 04/2022)</a:t>
-            </a:r>
-          </a:p>
-          <a:p>
-            <a:pPr>
-              <a:spcBef>
-                <a:spcPts val="1200"/>
-              </a:spcBef>
-            </a:pPr>
-            <a:endParaRPr lang="en-US" sz="1800" dirty="0"/>
-          </a:p>
-        </p:txBody>
-      </p:sp>
-      <p:sp>
-        <p:nvSpPr>
-          <p:cNvPr id="5" name="Titel 4"/>
-          <p:cNvSpPr>
-            <a:spLocks noGrp="1"/>
-          </p:cNvSpPr>
-          <p:nvPr>
-            <p:ph type="title"/>
-          </p:nvPr>
-        </p:nvSpPr>
-        <p:spPr>
-          <a:xfrm>
-            <a:off x="588206" y="453542"/>
-            <a:ext cx="8229240" cy="478905"/>
-          </a:xfrm>
-        </p:spPr>
-        <p:txBody>
-          <a:bodyPr/>
-          <a:lstStyle/>
-          <a:p>
-            <a:r>
-              <a:rPr lang="en-GB" dirty="0"/>
-              <a:t>Changes</a:t>
-            </a:r>
-          </a:p>
-        </p:txBody>
-      </p:sp>
-    </p:spTree>
-    <p:extLst>
-      <p:ext uri="{BB962C8B-B14F-4D97-AF65-F5344CB8AC3E}">
-        <p14:creationId xmlns:p14="http://schemas.microsoft.com/office/powerpoint/2010/main" val="3711980566"/>
       </p:ext>
     </p:extLst>
   </p:cSld>

</xml_diff>